<commit_message>
Corrected tyos in slides
</commit_message>
<xml_diff>
--- a/LectureSlides/11_PropertiesOfTimeSeries.pptx
+++ b/LectureSlides/11_PropertiesOfTimeSeries.pptx
@@ -372,7 +372,7 @@
           <a:p>
             <a:fld id="{241EB5C9-1307-BA42-ABA2-0BC069CD8E7F}" type="datetimeFigureOut">
               <a:rPr lang="en-US" smtClean="0"/>
-              <a:t>10/22/2025</a:t>
+              <a:t>10/29/2026</a:t>
             </a:fld>
             <a:endParaRPr lang="en-US"/>
           </a:p>
@@ -540,7 +540,7 @@
           <a:p>
             <a:fld id="{241EB5C9-1307-BA42-ABA2-0BC069CD8E7F}" type="datetimeFigureOut">
               <a:rPr lang="en-US" smtClean="0"/>
-              <a:t>10/22/2025</a:t>
+              <a:t>10/29/2026</a:t>
             </a:fld>
             <a:endParaRPr lang="en-US"/>
           </a:p>
@@ -718,7 +718,7 @@
           <a:p>
             <a:fld id="{241EB5C9-1307-BA42-ABA2-0BC069CD8E7F}" type="datetimeFigureOut">
               <a:rPr lang="en-US" smtClean="0"/>
-              <a:t>10/22/2025</a:t>
+              <a:t>10/29/2026</a:t>
             </a:fld>
             <a:endParaRPr lang="en-US"/>
           </a:p>
@@ -886,7 +886,7 @@
           <a:p>
             <a:fld id="{241EB5C9-1307-BA42-ABA2-0BC069CD8E7F}" type="datetimeFigureOut">
               <a:rPr lang="en-US" smtClean="0"/>
-              <a:t>10/22/2025</a:t>
+              <a:t>10/29/2026</a:t>
             </a:fld>
             <a:endParaRPr lang="en-US"/>
           </a:p>
@@ -1131,7 +1131,7 @@
           <a:p>
             <a:fld id="{241EB5C9-1307-BA42-ABA2-0BC069CD8E7F}" type="datetimeFigureOut">
               <a:rPr lang="en-US" smtClean="0"/>
-              <a:t>10/22/2025</a:t>
+              <a:t>10/29/2026</a:t>
             </a:fld>
             <a:endParaRPr lang="en-US"/>
           </a:p>
@@ -1416,7 +1416,7 @@
           <a:p>
             <a:fld id="{241EB5C9-1307-BA42-ABA2-0BC069CD8E7F}" type="datetimeFigureOut">
               <a:rPr lang="en-US" smtClean="0"/>
-              <a:t>10/22/2025</a:t>
+              <a:t>10/29/2026</a:t>
             </a:fld>
             <a:endParaRPr lang="en-US"/>
           </a:p>
@@ -1835,7 +1835,7 @@
           <a:p>
             <a:fld id="{241EB5C9-1307-BA42-ABA2-0BC069CD8E7F}" type="datetimeFigureOut">
               <a:rPr lang="en-US" smtClean="0"/>
-              <a:t>10/22/2025</a:t>
+              <a:t>10/29/2026</a:t>
             </a:fld>
             <a:endParaRPr lang="en-US"/>
           </a:p>
@@ -1952,7 +1952,7 @@
           <a:p>
             <a:fld id="{241EB5C9-1307-BA42-ABA2-0BC069CD8E7F}" type="datetimeFigureOut">
               <a:rPr lang="en-US" smtClean="0"/>
-              <a:t>10/22/2025</a:t>
+              <a:t>10/29/2026</a:t>
             </a:fld>
             <a:endParaRPr lang="en-US"/>
           </a:p>
@@ -2047,7 +2047,7 @@
           <a:p>
             <a:fld id="{241EB5C9-1307-BA42-ABA2-0BC069CD8E7F}" type="datetimeFigureOut">
               <a:rPr lang="en-US" smtClean="0"/>
-              <a:t>10/22/2025</a:t>
+              <a:t>10/29/2026</a:t>
             </a:fld>
             <a:endParaRPr lang="en-US"/>
           </a:p>
@@ -2322,7 +2322,7 @@
           <a:p>
             <a:fld id="{241EB5C9-1307-BA42-ABA2-0BC069CD8E7F}" type="datetimeFigureOut">
               <a:rPr lang="en-US" smtClean="0"/>
-              <a:t>10/22/2025</a:t>
+              <a:t>10/29/2026</a:t>
             </a:fld>
             <a:endParaRPr lang="en-US"/>
           </a:p>
@@ -2574,7 +2574,7 @@
           <a:p>
             <a:fld id="{241EB5C9-1307-BA42-ABA2-0BC069CD8E7F}" type="datetimeFigureOut">
               <a:rPr lang="en-US" smtClean="0"/>
-              <a:t>10/22/2025</a:t>
+              <a:t>10/29/2026</a:t>
             </a:fld>
             <a:endParaRPr lang="en-US"/>
           </a:p>
@@ -2785,7 +2785,7 @@
           <a:p>
             <a:fld id="{241EB5C9-1307-BA42-ABA2-0BC069CD8E7F}" type="datetimeFigureOut">
               <a:rPr lang="en-US" smtClean="0"/>
-              <a:t>10/22/2025</a:t>
+              <a:t>10/29/2026</a:t>
             </a:fld>
             <a:endParaRPr lang="en-US"/>
           </a:p>
@@ -4817,7 +4817,7 @@
                         <m:sSub>
                           <m:sSubPr>
                             <m:ctrlPr>
-                              <a:rPr lang="ar-AE" i="1">
+                              <a:rPr lang="en-US" b="0" i="1" smtClean="0">
                                 <a:latin typeface="Cambria Math" panose="02040503050406030204" pitchFamily="18" charset="0"/>
                               </a:rPr>
                             </m:ctrlPr>
@@ -4848,7 +4848,7 @@
                         <m:sSub>
                           <m:sSubPr>
                             <m:ctrlPr>
-                              <a:rPr lang="ar-AE" i="1">
+                              <a:rPr lang="en-US" b="0" i="1" smtClean="0">
                                 <a:latin typeface="Cambria Math" panose="02040503050406030204" pitchFamily="18" charset="0"/>
                               </a:rPr>
                             </m:ctrlPr>
@@ -4879,7 +4879,7 @@
                         <m:sSub>
                           <m:sSubPr>
                             <m:ctrlPr>
-                              <a:rPr lang="ar-AE" i="1">
+                              <a:rPr lang="en-US" b="0" i="1" smtClean="0">
                                 <a:latin typeface="Cambria Math" panose="02040503050406030204" pitchFamily="18" charset="0"/>
                               </a:rPr>
                             </m:ctrlPr>
@@ -4910,7 +4910,7 @@
                         <m:sSub>
                           <m:sSubPr>
                             <m:ctrlPr>
-                              <a:rPr lang="ar-AE" i="1">
+                              <a:rPr lang="en-US" b="0" i="1" smtClean="0">
                                 <a:latin typeface="Cambria Math" panose="02040503050406030204" pitchFamily="18" charset="0"/>
                               </a:rPr>
                             </m:ctrlPr>
@@ -4999,7 +4999,7 @@
                     <m:d>
                       <m:dPr>
                         <m:ctrlPr>
-                          <a:rPr lang="ar-AE" i="1">
+                          <a:rPr lang="ar-AE">
                             <a:latin typeface="Cambria Math" panose="02040503050406030204" pitchFamily="18" charset="0"/>
                           </a:rPr>
                         </m:ctrlPr>
@@ -5009,13 +5009,7 @@
                           <a:rPr lang="ar-AE">
                             <a:latin typeface="Cambria Math" panose="02040503050406030204" pitchFamily="18" charset="0"/>
                           </a:rPr>
-                          <m:t>0</m:t>
-                        </m:r>
-                        <m:r>
-                          <a:rPr lang="ar-AE">
-                            <a:latin typeface="Cambria Math" panose="02040503050406030204" pitchFamily="18" charset="0"/>
-                          </a:rPr>
-                          <m:t>,</m:t>
+                          <m:t>0,</m:t>
                         </m:r>
                         <m:r>
                           <a:rPr lang="ar-AE">
@@ -5033,13 +5027,7 @@
                           <a:rPr lang="ar-AE">
                             <a:latin typeface="Cambria Math" panose="02040503050406030204" pitchFamily="18" charset="0"/>
                           </a:rPr>
-                          <m:t>,</m:t>
-                        </m:r>
-                        <m:r>
-                          <a:rPr lang="ar-AE">
-                            <a:latin typeface="Cambria Math" panose="02040503050406030204" pitchFamily="18" charset="0"/>
-                          </a:rPr>
-                          <m:t>2</m:t>
+                          <m:t>,2</m:t>
                         </m:r>
                         <m:r>
                           <a:rPr lang="ar-AE">
@@ -5069,19 +5057,7 @@
                           <a:rPr lang="en-US" b="0" i="0" smtClean="0">
                             <a:latin typeface="Cambria Math" panose="02040503050406030204" pitchFamily="18" charset="0"/>
                           </a:rPr>
-                          <m:t>−</m:t>
-                        </m:r>
-                        <m:r>
-                          <a:rPr lang="en-US" b="0" i="0" smtClean="0">
-                            <a:latin typeface="Cambria Math" panose="02040503050406030204" pitchFamily="18" charset="0"/>
-                          </a:rPr>
-                          <m:t>1</m:t>
-                        </m:r>
-                        <m:r>
-                          <a:rPr lang="en-US" b="0" i="0" smtClean="0">
-                            <a:latin typeface="Cambria Math" panose="02040503050406030204" pitchFamily="18" charset="0"/>
-                          </a:rPr>
-                          <m:t> </m:t>
+                          <m:t>−1 </m:t>
                         </m:r>
                         <m:r>
                           <a:rPr lang="ar-AE">
@@ -5686,7 +5662,7 @@
                         <m:sSub>
                           <m:sSubPr>
                             <m:ctrlPr>
-                              <a:rPr lang="ar-AE" i="1">
+                              <a:rPr lang="ar-AE">
                                 <a:latin typeface="Cambria Math" panose="02040503050406030204" pitchFamily="18" charset="0"/>
                               </a:rPr>
                             </m:ctrlPr>
@@ -5717,7 +5693,7 @@
                         <m:sSub>
                           <m:sSubPr>
                             <m:ctrlPr>
-                              <a:rPr lang="ar-AE" i="1">
+                              <a:rPr lang="ar-AE">
                                 <a:latin typeface="Cambria Math" panose="02040503050406030204" pitchFamily="18" charset="0"/>
                               </a:rPr>
                             </m:ctrlPr>
@@ -5748,7 +5724,7 @@
                         <m:sSub>
                           <m:sSubPr>
                             <m:ctrlPr>
-                              <a:rPr lang="ar-AE" i="1">
+                              <a:rPr lang="ar-AE">
                                 <a:latin typeface="Cambria Math" panose="02040503050406030204" pitchFamily="18" charset="0"/>
                               </a:rPr>
                             </m:ctrlPr>
@@ -5779,7 +5755,7 @@
                         <m:sSub>
                           <m:sSubPr>
                             <m:ctrlPr>
-                              <a:rPr lang="ar-AE" i="1">
+                              <a:rPr lang="ar-AE">
                                 <a:latin typeface="Cambria Math" panose="02040503050406030204" pitchFamily="18" charset="0"/>
                               </a:rPr>
                             </m:ctrlPr>
@@ -5820,10 +5796,7 @@
                 </a:pPr>
                 <a14:m>
                   <m:oMathPara xmlns:m="http://schemas.openxmlformats.org/officeDocument/2006/math">
-                    <m:oMathParaPr>
-                      <m:jc m:val="centerGroup"/>
-                    </m:oMathParaPr>
-                    <m:oMath xmlns:m="http://schemas.openxmlformats.org/officeDocument/2006/math">
+                    <m:oMath>
                       <m:r>
                         <a:rPr lang="en-US" b="0" i="1" smtClean="0">
                           <a:latin typeface="Cambria Math" panose="02040503050406030204" pitchFamily="18" charset="0"/>
@@ -5958,7 +5931,7 @@
                           <m:sSub>
                             <m:sSubPr>
                               <m:ctrlPr>
-                                <a:rPr lang="en-US" i="1">
+                                <a:rPr lang="en-US" b="0" i="1" smtClean="0">
                                   <a:latin typeface="Cambria Math" panose="02040503050406030204" pitchFamily="18" charset="0"/>
                                 </a:rPr>
                               </m:ctrlPr>
@@ -6050,19 +6023,14 @@
                             <a:rPr lang="en-US" b="0" i="1" smtClean="0">
                               <a:latin typeface="Cambria Math" panose="02040503050406030204" pitchFamily="18" charset="0"/>
                             </a:rPr>
-                            <m:t>0</m:t>
-                          </m:r>
-                          <m:r>
-                            <a:rPr lang="en-US" b="0" i="1" smtClean="0">
-                              <a:latin typeface="Cambria Math" panose="02040503050406030204" pitchFamily="18" charset="0"/>
-                            </a:rPr>
-                            <m:t>,</m:t>
+                            <m:t>0,</m:t>
                           </m:r>
                           <m:sSup>
                             <m:sSupPr>
                               <m:ctrlPr>
                                 <a:rPr lang="en-US" b="0" i="1" smtClean="0">
                                   <a:latin typeface="Cambria Math" panose="02040503050406030204" pitchFamily="18" charset="0"/>
+                                  <a:ea typeface="Cambria Math" panose="02040503050406030204" pitchFamily="18" charset="0"/>
                                 </a:rPr>
                               </m:ctrlPr>
                             </m:sSupPr>
@@ -6972,10 +6940,7 @@
                 <a:pPr lvl="0"/>
                 <a14:m>
                   <m:oMathPara xmlns:m="http://schemas.openxmlformats.org/officeDocument/2006/math">
-                    <m:oMathParaPr>
-                      <m:jc m:val="centerGroup"/>
-                    </m:oMathParaPr>
-                    <m:oMath xmlns:m="http://schemas.openxmlformats.org/officeDocument/2006/math">
+                    <m:oMath>
                       <m:sSub>
                         <m:sSubPr>
                           <m:ctrlPr>
@@ -7026,19 +6991,14 @@
                             <a:rPr lang="en-US" sz="2000" i="1">
                               <a:latin typeface="Cambria Math" panose="02040503050406030204" pitchFamily="18" charset="0"/>
                             </a:rPr>
-                            <m:t>0</m:t>
-                          </m:r>
-                          <m:r>
-                            <a:rPr lang="en-US" sz="2000" i="1">
-                              <a:latin typeface="Cambria Math" panose="02040503050406030204" pitchFamily="18" charset="0"/>
-                            </a:rPr>
-                            <m:t>,</m:t>
+                            <m:t>0,</m:t>
                           </m:r>
                           <m:sSup>
                             <m:sSupPr>
                               <m:ctrlPr>
                                 <a:rPr lang="en-US" sz="2000" i="1">
                                   <a:latin typeface="Cambria Math" panose="02040503050406030204" pitchFamily="18" charset="0"/>
+                                  <a:ea typeface="Cambria Math" panose="02040503050406030204" pitchFamily="18" charset="0"/>
                                 </a:rPr>
                               </m:ctrlPr>
                             </m:sSupPr>
@@ -8296,8 +8256,8 @@
           </a:p>
         </p:txBody>
       </p:sp>
-      <mc:AlternateContent xmlns:mc="http://schemas.openxmlformats.org/markup-compatibility/2006" xmlns:a14="http://schemas.microsoft.com/office/drawing/2010/main">
-        <mc:Choice Requires="a14">
+      <mc:AlternateContent xmlns:mc="http://schemas.openxmlformats.org/markup-compatibility/2006">
+        <mc:Choice xmlns:a14="http://schemas.microsoft.com/office/drawing/2010/main" Requires="a14">
           <p:sp>
             <p:nvSpPr>
               <p:cNvPr id="3" name="Content Placeholder 2"/>
@@ -8351,11 +8311,11 @@
                     <m:oMathParaPr>
                       <m:jc m:val="center"/>
                     </m:oMathParaPr>
-                    <m:oMath xmlns:m="http://schemas.openxmlformats.org/officeDocument/2006/math">
+                    <m:oMath>
                       <m:sSub>
                         <m:sSubPr>
                           <m:ctrlPr>
-                            <a:rPr lang="ar-AE" i="1">
+                            <a:rPr lang="ar-AE">
                               <a:latin typeface="Cambria Math" panose="02040503050406030204" pitchFamily="18" charset="0"/>
                             </a:rPr>
                           </m:ctrlPr>
@@ -8395,7 +8355,7 @@
                           <m:sSub>
                             <m:sSubPr>
                               <m:ctrlPr>
-                                <a:rPr lang="ar-AE" i="1">
+                                <a:rPr lang="ar-AE">
                                   <a:latin typeface="Cambria Math" panose="02040503050406030204" pitchFamily="18" charset="0"/>
                                 </a:rPr>
                               </m:ctrlPr>
@@ -8428,7 +8388,7 @@
                           <m:sSup>
                             <m:sSupPr>
                               <m:ctrlPr>
-                                <a:rPr lang="ar-AE" i="1">
+                                <a:rPr lang="ar-AE">
                                   <a:latin typeface="Cambria Math" panose="02040503050406030204" pitchFamily="18" charset="0"/>
                                 </a:rPr>
                               </m:ctrlPr>
@@ -8461,7 +8421,7 @@
                       <m:f>
                         <m:fPr>
                           <m:ctrlPr>
-                            <a:rPr lang="ar-AE" i="1">
+                            <a:rPr lang="ar-AE">
                               <a:latin typeface="Cambria Math" panose="02040503050406030204" pitchFamily="18" charset="0"/>
                             </a:rPr>
                           </m:ctrlPr>
@@ -8484,7 +8444,7 @@
                           <m:sSup>
                             <m:sSupPr>
                               <m:ctrlPr>
-                                <a:rPr lang="ar-AE" i="1">
+                                <a:rPr lang="ar-AE">
                                   <a:latin typeface="Cambria Math" panose="02040503050406030204" pitchFamily="18" charset="0"/>
                                 </a:rPr>
                               </m:ctrlPr>
@@ -8513,7 +8473,7 @@
                           <m:chr m:val="∑"/>
                           <m:limLoc m:val="undOvr"/>
                           <m:ctrlPr>
-                            <a:rPr lang="ar-AE" i="1">
+                            <a:rPr lang="ar-AE">
                               <a:latin typeface="Cambria Math" panose="02040503050406030204" pitchFamily="18" charset="0"/>
                             </a:rPr>
                           </m:ctrlPr>
@@ -8529,13 +8489,7 @@
                             <a:rPr lang="ar-AE">
                               <a:latin typeface="Cambria Math" panose="02040503050406030204" pitchFamily="18" charset="0"/>
                             </a:rPr>
-                            <m:t>=</m:t>
-                          </m:r>
-                          <m:r>
-                            <a:rPr lang="ar-AE">
-                              <a:latin typeface="Cambria Math" panose="02040503050406030204" pitchFamily="18" charset="0"/>
-                            </a:rPr>
-                            <m:t>1</m:t>
+                            <m:t>=1</m:t>
                           </m:r>
                         </m:sub>
                         <m:sup>
@@ -8550,7 +8504,7 @@
                           <m:d>
                             <m:dPr>
                               <m:ctrlPr>
-                                <a:rPr lang="ar-AE" i="1" smtClean="0">
+                                <a:rPr lang="ar-AE" i="1">
                                   <a:latin typeface="Cambria Math" panose="02040503050406030204" pitchFamily="18" charset="0"/>
                                 </a:rPr>
                               </m:ctrlPr>
@@ -8559,7 +8513,7 @@
                               <m:sSub>
                                 <m:sSubPr>
                                   <m:ctrlPr>
-                                    <a:rPr lang="ar-AE" i="1">
+                                    <a:rPr lang="ar-AE">
                                       <a:latin typeface="Cambria Math" panose="02040503050406030204" pitchFamily="18" charset="0"/>
                                     </a:rPr>
                                   </m:ctrlPr>
@@ -8615,7 +8569,7 @@
                           <m:sSub>
                             <m:sSubPr>
                               <m:ctrlPr>
-                                <a:rPr lang="ar-AE" i="1">
+                                <a:rPr lang="ar-AE">
                                   <a:latin typeface="Cambria Math" panose="02040503050406030204" pitchFamily="18" charset="0"/>
                                 </a:rPr>
                               </m:ctrlPr>
@@ -8683,7 +8637,7 @@
                     <m:sSub>
                       <m:sSubPr>
                         <m:ctrlPr>
-                          <a:rPr lang="ar-AE" i="1" smtClean="0">
+                          <a:rPr lang="ar-AE">
                             <a:latin typeface="Cambria Math" panose="02040503050406030204" pitchFamily="18" charset="0"/>
                           </a:rPr>
                         </m:ctrlPr>
@@ -8716,7 +8670,7 @@
                         <m:chr m:val="∑"/>
                         <m:limLoc m:val="undOvr"/>
                         <m:ctrlPr>
-                          <a:rPr lang="ar-AE" i="1">
+                          <a:rPr lang="ar-AE">
                             <a:latin typeface="Cambria Math" panose="02040503050406030204" pitchFamily="18" charset="0"/>
                           </a:rPr>
                         </m:ctrlPr>
@@ -8732,13 +8686,7 @@
                           <a:rPr lang="ar-AE">
                             <a:latin typeface="Cambria Math" panose="02040503050406030204" pitchFamily="18" charset="0"/>
                           </a:rPr>
-                          <m:t>=</m:t>
-                        </m:r>
-                        <m:r>
-                          <a:rPr lang="ar-AE">
-                            <a:latin typeface="Cambria Math" panose="02040503050406030204" pitchFamily="18" charset="0"/>
-                          </a:rPr>
-                          <m:t>1</m:t>
+                          <m:t>=1</m:t>
                         </m:r>
                       </m:sub>
                       <m:sup>
@@ -8762,7 +8710,7 @@
                             <m:sSub>
                               <m:sSubPr>
                                 <m:ctrlPr>
-                                  <a:rPr lang="ar-AE" i="1">
+                                  <a:rPr lang="ar-AE">
                                     <a:latin typeface="Cambria Math" panose="02040503050406030204" pitchFamily="18" charset="0"/>
                                   </a:rPr>
                                 </m:ctrlPr>
@@ -8818,7 +8766,7 @@
                         <m:sSub>
                           <m:sSubPr>
                             <m:ctrlPr>
-                              <a:rPr lang="ar-AE" i="1">
+                              <a:rPr lang="ar-AE">
                                 <a:latin typeface="Cambria Math" panose="02040503050406030204" pitchFamily="18" charset="0"/>
                               </a:rPr>
                             </m:ctrlPr>
@@ -8890,7 +8838,7 @@
                     <m:sSub>
                       <m:sSubPr>
                         <m:ctrlPr>
-                          <a:rPr lang="ar-AE" i="1" smtClean="0">
+                          <a:rPr lang="ar-AE">
                             <a:latin typeface="Cambria Math" panose="02040503050406030204" pitchFamily="18" charset="0"/>
                           </a:rPr>
                         </m:ctrlPr>
@@ -8971,7 +8919,7 @@
                     <m:sSup>
                       <m:sSupPr>
                         <m:ctrlPr>
-                          <a:rPr lang="ar-AE" i="1" smtClean="0">
+                          <a:rPr lang="ar-AE">
                             <a:latin typeface="Cambria Math" panose="02040503050406030204" pitchFamily="18" charset="0"/>
                           </a:rPr>
                         </m:ctrlPr>
@@ -9047,7 +8995,7 @@
                     <m:sSub>
                       <m:sSubPr>
                         <m:ctrlPr>
-                          <a:rPr lang="ar-AE" i="1">
+                          <a:rPr lang="ar-AE">
                             <a:latin typeface="Cambria Math" panose="02040503050406030204" pitchFamily="18" charset="0"/>
                           </a:rPr>
                         </m:ctrlPr>
@@ -9073,13 +9021,7 @@
                       <a:rPr lang="ar-AE">
                         <a:latin typeface="Cambria Math" panose="02040503050406030204" pitchFamily="18" charset="0"/>
                       </a:rPr>
-                      <m:t>=</m:t>
-                    </m:r>
-                    <m:r>
-                      <a:rPr lang="ar-AE">
-                        <a:latin typeface="Cambria Math" panose="02040503050406030204" pitchFamily="18" charset="0"/>
-                      </a:rPr>
-                      <m:t>1</m:t>
+                      <m:t>=1</m:t>
                     </m:r>
                   </m:oMath>
                 </a14:m>
@@ -9097,36 +9039,19 @@
                       <a:rPr lang="en-US">
                         <a:latin typeface="Cambria Math" panose="02040503050406030204" pitchFamily="18" charset="0"/>
                       </a:rPr>
-                      <m:t>−</m:t>
+                      <m:t>−1.0</m:t>
                     </m:r>
                     <m:r>
-                      <a:rPr lang="en-US">
+                      <a:rPr lang="en-US" i="1" smtClean="0">
                         <a:latin typeface="Cambria Math" panose="02040503050406030204" pitchFamily="18" charset="0"/>
+                        <a:ea typeface="Cambria Math" panose="02040503050406030204" pitchFamily="18" charset="0"/>
                       </a:rPr>
-                      <m:t>1</m:t>
-                    </m:r>
-                    <m:r>
-                      <a:rPr lang="en-US">
-                        <a:latin typeface="Cambria Math" panose="02040503050406030204" pitchFamily="18" charset="0"/>
-                      </a:rPr>
-                      <m:t>.</m:t>
-                    </m:r>
-                    <m:r>
-                      <a:rPr lang="en-US">
-                        <a:latin typeface="Cambria Math" panose="02040503050406030204" pitchFamily="18" charset="0"/>
-                      </a:rPr>
-                      <m:t>0</m:t>
-                    </m:r>
-                    <m:r>
-                      <a:rPr lang="en-US">
-                        <a:latin typeface="Cambria Math" panose="02040503050406030204" pitchFamily="18" charset="0"/>
-                      </a:rPr>
-                      <m:t>≥</m:t>
+                      <m:t>≤</m:t>
                     </m:r>
                     <m:sSub>
                       <m:sSubPr>
                         <m:ctrlPr>
-                          <a:rPr lang="ar-AE" i="1">
+                          <a:rPr lang="ar-AE">
                             <a:latin typeface="Cambria Math" panose="02040503050406030204" pitchFamily="18" charset="0"/>
                           </a:rPr>
                         </m:ctrlPr>
@@ -9151,26 +9076,15 @@
                     <m:r>
                       <a:rPr lang="en-US">
                         <a:latin typeface="Cambria Math" panose="02040503050406030204" pitchFamily="18" charset="0"/>
+                        <a:ea typeface="Cambria Math" panose="02040503050406030204" pitchFamily="18" charset="0"/>
                       </a:rPr>
-                      <m:t>≥</m:t>
+                      <m:t>≤</m:t>
                     </m:r>
                     <m:r>
                       <a:rPr lang="en-US">
                         <a:latin typeface="Cambria Math" panose="02040503050406030204" pitchFamily="18" charset="0"/>
                       </a:rPr>
-                      <m:t>1</m:t>
-                    </m:r>
-                    <m:r>
-                      <a:rPr lang="en-US">
-                        <a:latin typeface="Cambria Math" panose="02040503050406030204" pitchFamily="18" charset="0"/>
-                      </a:rPr>
-                      <m:t>.</m:t>
-                    </m:r>
-                    <m:r>
-                      <a:rPr lang="en-US">
-                        <a:latin typeface="Cambria Math" panose="02040503050406030204" pitchFamily="18" charset="0"/>
-                      </a:rPr>
-                      <m:t>0</m:t>
+                      <m:t>1.0</m:t>
                     </m:r>
                   </m:oMath>
                 </a14:m>
@@ -9179,7 +9093,7 @@
             </p:txBody>
           </p:sp>
         </mc:Choice>
-        <mc:Fallback xmlns="">
+        <mc:Fallback>
           <p:sp>
             <p:nvSpPr>
               <p:cNvPr id="3" name="Content Placeholder 2"/>
@@ -9396,8 +9310,8 @@
           </a:p>
         </p:txBody>
       </p:sp>
-      <mc:AlternateContent xmlns:mc="http://schemas.openxmlformats.org/markup-compatibility/2006" xmlns:a14="http://schemas.microsoft.com/office/drawing/2010/main">
-        <mc:Choice Requires="a14">
+      <mc:AlternateContent xmlns:mc="http://schemas.openxmlformats.org/markup-compatibility/2006">
+        <mc:Choice xmlns:a14="http://schemas.microsoft.com/office/drawing/2010/main" Requires="a14">
           <p:sp>
             <p:nvSpPr>
               <p:cNvPr id="3" name="Content Placeholder 2"/>
@@ -9514,11 +9428,7 @@
                 </a:pPr>
                 <a:r>
                   <a:rPr lang="en-US" dirty="0"/>
-                  <a:t>Compute the residual from the </a:t>
-                </a:r>
-                <a:r>
-                  <a:rPr lang="en-US" dirty="0" err="1"/>
-                  <a:t>prediciton</a:t>
+                  <a:t>Compute the residual from the prediction</a:t>
                 </a:r>
                 <a:endParaRPr dirty="0"/>
               </a:p>
@@ -9553,7 +9463,7 @@
             </p:txBody>
           </p:sp>
         </mc:Choice>
-        <mc:Fallback xmlns="">
+        <mc:Fallback>
           <p:sp>
             <p:nvSpPr>
               <p:cNvPr id="3" name="Content Placeholder 2"/>
@@ -10026,13 +9936,7 @@
                       <a:rPr sz="2000">
                         <a:latin typeface="Cambria Math" panose="02040503050406030204" pitchFamily="18" charset="0"/>
                       </a:rPr>
-                      <m:t>&gt;</m:t>
-                    </m:r>
-                    <m:r>
-                      <a:rPr sz="2000">
-                        <a:latin typeface="Cambria Math" panose="02040503050406030204" pitchFamily="18" charset="0"/>
-                      </a:rPr>
-                      <m:t>0</m:t>
+                      <m:t>&gt;0</m:t>
                     </m:r>
                   </m:oMath>
                 </a14:m>
@@ -10338,8 +10242,8 @@
           </a:p>
         </p:txBody>
       </p:sp>
-      <mc:AlternateContent xmlns:mc="http://schemas.openxmlformats.org/markup-compatibility/2006" xmlns:a14="http://schemas.microsoft.com/office/drawing/2010/main">
-        <mc:Choice Requires="a14">
+      <mc:AlternateContent xmlns:mc="http://schemas.openxmlformats.org/markup-compatibility/2006">
+        <mc:Choice xmlns:a14="http://schemas.microsoft.com/office/drawing/2010/main" Requires="a14">
           <p:sp>
             <p:nvSpPr>
               <p:cNvPr id="3" name="Content Placeholder 2"/>
@@ -10353,7 +10257,7 @@
             <p:spPr/>
             <p:txBody>
               <a:bodyPr>
-                <a:normAutofit fontScale="85000" lnSpcReduction="10000"/>
+                <a:normAutofit fontScale="92500" lnSpcReduction="20000"/>
               </a:bodyPr>
               <a:lstStyle/>
               <a:p>
@@ -10392,7 +10296,7 @@
                     <m:sSub>
                       <m:sSubPr>
                         <m:ctrlPr>
-                          <a:rPr lang="ar-AE" i="1">
+                          <a:rPr lang="ar-AE">
                             <a:latin typeface="Cambria Math" panose="02040503050406030204" pitchFamily="18" charset="0"/>
                           </a:rPr>
                         </m:ctrlPr>
@@ -10430,7 +10334,7 @@
                     <m:oMathParaPr>
                       <m:jc m:val="center"/>
                     </m:oMathParaPr>
-                    <m:oMath xmlns:m="http://schemas.openxmlformats.org/officeDocument/2006/math">
+                    <m:oMath>
                       <m:r>
                         <a:rPr lang="ar-AE">
                           <a:latin typeface="Cambria Math" panose="02040503050406030204" pitchFamily="18" charset="0"/>
@@ -10452,7 +10356,7 @@
                       <m:d>
                         <m:dPr>
                           <m:ctrlPr>
-                            <a:rPr lang="ar-AE" i="1">
+                            <a:rPr lang="ar-AE">
                               <a:latin typeface="Cambria Math" panose="02040503050406030204" pitchFamily="18" charset="0"/>
                             </a:rPr>
                           </m:ctrlPr>
@@ -10468,13 +10372,7 @@
                             <a:rPr lang="ar-AE">
                               <a:latin typeface="Cambria Math" panose="02040503050406030204" pitchFamily="18" charset="0"/>
                             </a:rPr>
-                            <m:t>+</m:t>
-                          </m:r>
-                          <m:r>
-                            <a:rPr lang="ar-AE">
-                              <a:latin typeface="Cambria Math" panose="02040503050406030204" pitchFamily="18" charset="0"/>
-                            </a:rPr>
-                            <m:t>2</m:t>
+                            <m:t>+2</m:t>
                           </m:r>
                         </m:e>
                       </m:d>
@@ -10483,7 +10381,7 @@
                           <m:chr m:val="∑"/>
                           <m:limLoc m:val="undOvr"/>
                           <m:ctrlPr>
-                            <a:rPr lang="ar-AE" i="1">
+                            <a:rPr lang="ar-AE">
                               <a:latin typeface="Cambria Math" panose="02040503050406030204" pitchFamily="18" charset="0"/>
                             </a:rPr>
                           </m:ctrlPr>
@@ -10499,13 +10397,7 @@
                             <a:rPr lang="ar-AE">
                               <a:latin typeface="Cambria Math" panose="02040503050406030204" pitchFamily="18" charset="0"/>
                             </a:rPr>
-                            <m:t>=</m:t>
-                          </m:r>
-                          <m:r>
-                            <a:rPr lang="ar-AE">
-                              <a:latin typeface="Cambria Math" panose="02040503050406030204" pitchFamily="18" charset="0"/>
-                            </a:rPr>
-                            <m:t>1</m:t>
+                            <m:t>=1</m:t>
                           </m:r>
                         </m:sub>
                         <m:sup>
@@ -10513,7 +10405,7 @@
                             <a:rPr lang="ar-AE">
                               <a:latin typeface="Cambria Math" panose="02040503050406030204" pitchFamily="18" charset="0"/>
                             </a:rPr>
-                            <m:t>h</m:t>
+                            <m:t>ℎ</m:t>
                           </m:r>
                         </m:sup>
                         <m:e>
@@ -10539,7 +10431,7 @@
                                     <m:accPr>
                                       <m:chr m:val="̂"/>
                                       <m:ctrlPr>
-                                        <a:rPr lang="ar-AE" i="1">
+                                        <a:rPr lang="ar-AE">
                                           <a:latin typeface="Cambria Math" panose="02040503050406030204" pitchFamily="18" charset="0"/>
                                         </a:rPr>
                                       </m:ctrlPr>
@@ -10610,7 +10502,7 @@
                     <m:sSup>
                       <m:sSupPr>
                         <m:ctrlPr>
-                          <a:rPr lang="ar-AE" i="1">
+                          <a:rPr lang="ar-AE">
                             <a:latin typeface="Cambria Math" panose="02040503050406030204" pitchFamily="18" charset="0"/>
                           </a:rPr>
                         </m:ctrlPr>
@@ -10679,7 +10571,11 @@
                 <a:pPr lvl="0"/>
                 <a:r>
                   <a:rPr lang="en-US" dirty="0"/>
-                  <a:t>Alternative hypothesis is serial correlation gives high values of Q statistic </a:t>
+                  <a:t>Reject null hypothesis of no </a:t>
+                </a:r>
+                <a:r>
+                  <a:rPr lang="en-US"/>
+                  <a:t>serial correlation</a:t>
                 </a:r>
                 <a:endParaRPr lang="en-US" dirty="0">
                   <a:latin typeface="Cambria Math" panose="02040503050406030204" pitchFamily="18" charset="0"/>
@@ -10689,7 +10585,7 @@
                 <a:pPr lvl="1"/>
                 <a:r>
                   <a:rPr lang="en-US" dirty="0"/>
-                  <a:t>Significant serial correlation </a:t>
+                  <a:t>high values of Q statistic </a:t>
                 </a:r>
                 <a14:m>
                   <m:oMath xmlns:m="http://schemas.openxmlformats.org/officeDocument/2006/math">
@@ -10710,7 +10606,7 @@
             </p:txBody>
           </p:sp>
         </mc:Choice>
-        <mc:Fallback xmlns="">
+        <mc:Fallback>
           <p:sp>
             <p:nvSpPr>
               <p:cNvPr id="3" name="Content Placeholder 2"/>
@@ -10725,7 +10621,7 @@
               <a:blipFill>
                 <a:blip r:embed="rId3"/>
                 <a:stretch>
-                  <a:fillRect l="-741" t="-1975"/>
+                  <a:fillRect l="-963" t="-3052"/>
                 </a:stretch>
               </a:blipFill>
             </p:spPr>
@@ -11228,14 +11124,11 @@
                 </a:pPr>
                 <a14:m>
                   <m:oMathPara xmlns:m="http://schemas.openxmlformats.org/officeDocument/2006/math">
-                    <m:oMathParaPr>
-                      <m:jc m:val="centerGroup"/>
-                    </m:oMathParaPr>
-                    <m:oMath xmlns:m="http://schemas.openxmlformats.org/officeDocument/2006/math">
+                    <m:oMath>
                       <m:sSub>
                         <m:sSubPr>
                           <m:ctrlPr>
-                            <a:rPr lang="ar-AE" i="1">
+                            <a:rPr lang="ar-AE">
                               <a:latin typeface="Cambria Math" panose="02040503050406030204" pitchFamily="18" charset="0"/>
                             </a:rPr>
                           </m:ctrlPr>
@@ -11266,7 +11159,7 @@
                       <m:sSub>
                         <m:sSubPr>
                           <m:ctrlPr>
-                            <a:rPr lang="ar-AE" i="1">
+                            <a:rPr lang="ar-AE">
                               <a:latin typeface="Cambria Math" panose="02040503050406030204" pitchFamily="18" charset="0"/>
                             </a:rPr>
                           </m:ctrlPr>
@@ -11297,7 +11190,7 @@
                       <m:sSub>
                         <m:sSubPr>
                           <m:ctrlPr>
-                            <a:rPr lang="ar-AE" i="1">
+                            <a:rPr lang="ar-AE">
                               <a:latin typeface="Cambria Math" panose="02040503050406030204" pitchFamily="18" charset="0"/>
                             </a:rPr>
                           </m:ctrlPr>
@@ -11321,13 +11214,7 @@
                             <a:rPr lang="ar-AE">
                               <a:latin typeface="Cambria Math" panose="02040503050406030204" pitchFamily="18" charset="0"/>
                             </a:rPr>
-                            <m:t>−</m:t>
-                          </m:r>
-                          <m:r>
-                            <a:rPr lang="ar-AE">
-                              <a:latin typeface="Cambria Math" panose="02040503050406030204" pitchFamily="18" charset="0"/>
-                            </a:rPr>
-                            <m:t>1</m:t>
+                            <m:t>−1</m:t>
                           </m:r>
                         </m:sub>
                       </m:sSub>
@@ -11393,19 +11280,14 @@
                             <a:rPr lang="ar-AE" i="1">
                               <a:latin typeface="Cambria Math" panose="02040503050406030204" pitchFamily="18" charset="0"/>
                             </a:rPr>
-                            <m:t>0</m:t>
-                          </m:r>
-                          <m:r>
-                            <a:rPr lang="ar-AE" i="1">
-                              <a:latin typeface="Cambria Math" panose="02040503050406030204" pitchFamily="18" charset="0"/>
-                            </a:rPr>
-                            <m:t>,</m:t>
+                            <m:t>0,</m:t>
                           </m:r>
                           <m:sSup>
                             <m:sSupPr>
                               <m:ctrlPr>
                                 <a:rPr lang="ar-AE" i="1">
                                   <a:latin typeface="Cambria Math" panose="02040503050406030204" pitchFamily="18" charset="0"/>
+                                  <a:ea typeface="Cambria Math" panose="02040503050406030204" pitchFamily="18" charset="0"/>
                                 </a:rPr>
                               </m:ctrlPr>
                             </m:sSupPr>
@@ -11447,14 +11329,11 @@
                 </a:pPr>
                 <a14:m>
                   <m:oMathPara xmlns:m="http://schemas.openxmlformats.org/officeDocument/2006/math">
-                    <m:oMathParaPr>
-                      <m:jc m:val="centerGroup"/>
-                    </m:oMathParaPr>
-                    <m:oMath xmlns:m="http://schemas.openxmlformats.org/officeDocument/2006/math">
+                    <m:oMath>
                       <m:sSub>
                         <m:sSubPr>
                           <m:ctrlPr>
-                            <a:rPr lang="ar-AE" i="1">
+                            <a:rPr lang="ar-AE">
                               <a:latin typeface="Cambria Math" panose="02040503050406030204" pitchFamily="18" charset="0"/>
                             </a:rPr>
                           </m:ctrlPr>
@@ -11485,7 +11364,7 @@
                       <m:sSub>
                         <m:sSubPr>
                           <m:ctrlPr>
-                            <a:rPr lang="ar-AE" i="1">
+                            <a:rPr lang="ar-AE">
                               <a:latin typeface="Cambria Math" panose="02040503050406030204" pitchFamily="18" charset="0"/>
                             </a:rPr>
                           </m:ctrlPr>
@@ -11509,13 +11388,7 @@
                             <a:rPr lang="ar-AE">
                               <a:latin typeface="Cambria Math" panose="02040503050406030204" pitchFamily="18" charset="0"/>
                             </a:rPr>
-                            <m:t>−</m:t>
-                          </m:r>
-                          <m:r>
-                            <a:rPr lang="ar-AE">
-                              <a:latin typeface="Cambria Math" panose="02040503050406030204" pitchFamily="18" charset="0"/>
-                            </a:rPr>
-                            <m:t>1</m:t>
+                            <m:t>−1</m:t>
                           </m:r>
                         </m:sub>
                       </m:sSub>
@@ -11528,7 +11401,7 @@
                       <m:sSub>
                         <m:sSubPr>
                           <m:ctrlPr>
-                            <a:rPr lang="ar-AE" i="1">
+                            <a:rPr lang="ar-AE">
                               <a:latin typeface="Cambria Math" panose="02040503050406030204" pitchFamily="18" charset="0"/>
                             </a:rPr>
                           </m:ctrlPr>
@@ -11570,11 +11443,11 @@
                     <m:oMathParaPr>
                       <m:jc m:val="center"/>
                     </m:oMathParaPr>
-                    <m:oMath xmlns:m="http://schemas.openxmlformats.org/officeDocument/2006/math">
+                    <m:oMath>
                       <m:sSub>
                         <m:sSubPr>
                           <m:ctrlPr>
-                            <a:rPr lang="ar-AE" i="1">
+                            <a:rPr lang="ar-AE">
                               <a:latin typeface="Cambria Math" panose="02040503050406030204" pitchFamily="18" charset="0"/>
                             </a:rPr>
                           </m:ctrlPr>
@@ -11605,7 +11478,7 @@
                       <m:sSub>
                         <m:sSubPr>
                           <m:ctrlPr>
-                            <a:rPr lang="ar-AE" i="1">
+                            <a:rPr lang="en-US" b="0" i="1" smtClean="0">
                               <a:latin typeface="Cambria Math" panose="02040503050406030204" pitchFamily="18" charset="0"/>
                             </a:rPr>
                           </m:ctrlPr>
@@ -11638,7 +11511,7 @@
                           <m:chr m:val="∑"/>
                           <m:limLoc m:val="undOvr"/>
                           <m:ctrlPr>
-                            <a:rPr lang="ar-AE" i="1">
+                            <a:rPr lang="ar-AE">
                               <a:latin typeface="Cambria Math" panose="02040503050406030204" pitchFamily="18" charset="0"/>
                             </a:rPr>
                           </m:ctrlPr>
@@ -11654,13 +11527,7 @@
                             <a:rPr lang="ar-AE">
                               <a:latin typeface="Cambria Math" panose="02040503050406030204" pitchFamily="18" charset="0"/>
                             </a:rPr>
-                            <m:t>=</m:t>
-                          </m:r>
-                          <m:r>
-                            <a:rPr lang="en-US" b="0" i="1" smtClean="0">
-                              <a:latin typeface="Cambria Math" panose="02040503050406030204" pitchFamily="18" charset="0"/>
-                            </a:rPr>
-                            <m:t>1</m:t>
+                            <m:t>=1</m:t>
                           </m:r>
                         </m:sub>
                         <m:sup>
@@ -11674,20 +11541,14 @@
                             <a:rPr lang="ar-AE">
                               <a:latin typeface="Cambria Math" panose="02040503050406030204" pitchFamily="18" charset="0"/>
                             </a:rPr>
-                            <m:t>−</m:t>
-                          </m:r>
-                          <m:r>
-                            <a:rPr lang="ar-AE">
-                              <a:latin typeface="Cambria Math" panose="02040503050406030204" pitchFamily="18" charset="0"/>
-                            </a:rPr>
-                            <m:t>1</m:t>
+                            <m:t>−1</m:t>
                           </m:r>
                         </m:sup>
                         <m:e>
                           <m:sSub>
                             <m:sSubPr>
                               <m:ctrlPr>
-                                <a:rPr lang="ar-AE" i="1">
+                                <a:rPr lang="ar-AE">
                                   <a:latin typeface="Cambria Math" panose="02040503050406030204" pitchFamily="18" charset="0"/>
                                 </a:rPr>
                               </m:ctrlPr>
@@ -12172,11 +12033,11 @@
                     <m:oMathParaPr>
                       <m:jc m:val="center"/>
                     </m:oMathParaPr>
-                    <m:oMath xmlns:m="http://schemas.openxmlformats.org/officeDocument/2006/math">
+                    <m:oMath>
                       <m:sSub>
                         <m:sSubPr>
                           <m:ctrlPr>
-                            <a:rPr lang="ar-AE" i="1">
+                            <a:rPr lang="ar-AE">
                               <a:latin typeface="Cambria Math" panose="02040503050406030204" pitchFamily="18" charset="0"/>
                             </a:rPr>
                           </m:ctrlPr>
@@ -12207,7 +12068,7 @@
                       <m:sSub>
                         <m:sSubPr>
                           <m:ctrlPr>
-                            <a:rPr lang="ar-AE" i="1">
+                            <a:rPr lang="en-US" b="0" i="1" smtClean="0">
                               <a:latin typeface="Cambria Math" panose="02040503050406030204" pitchFamily="18" charset="0"/>
                             </a:rPr>
                           </m:ctrlPr>
@@ -12240,7 +12101,7 @@
                           <m:chr m:val="∑"/>
                           <m:limLoc m:val="undOvr"/>
                           <m:ctrlPr>
-                            <a:rPr lang="ar-AE" i="1">
+                            <a:rPr lang="ar-AE">
                               <a:latin typeface="Cambria Math" panose="02040503050406030204" pitchFamily="18" charset="0"/>
                             </a:rPr>
                           </m:ctrlPr>
@@ -12256,13 +12117,7 @@
                             <a:rPr lang="ar-AE">
                               <a:latin typeface="Cambria Math" panose="02040503050406030204" pitchFamily="18" charset="0"/>
                             </a:rPr>
-                            <m:t>=</m:t>
-                          </m:r>
-                          <m:r>
-                            <a:rPr lang="ar-AE">
-                              <a:latin typeface="Cambria Math" panose="02040503050406030204" pitchFamily="18" charset="0"/>
-                            </a:rPr>
-                            <m:t>0</m:t>
+                            <m:t>=0</m:t>
                           </m:r>
                         </m:sub>
                         <m:sup>
@@ -12276,20 +12131,14 @@
                             <a:rPr lang="ar-AE">
                               <a:latin typeface="Cambria Math" panose="02040503050406030204" pitchFamily="18" charset="0"/>
                             </a:rPr>
-                            <m:t>−</m:t>
-                          </m:r>
-                          <m:r>
-                            <a:rPr lang="ar-AE">
-                              <a:latin typeface="Cambria Math" panose="02040503050406030204" pitchFamily="18" charset="0"/>
-                            </a:rPr>
-                            <m:t>1</m:t>
+                            <m:t>−1</m:t>
                           </m:r>
                         </m:sup>
                         <m:e>
                           <m:sSub>
                             <m:sSubPr>
                               <m:ctrlPr>
-                                <a:rPr lang="ar-AE" i="1">
+                                <a:rPr lang="ar-AE">
                                   <a:latin typeface="Cambria Math" panose="02040503050406030204" pitchFamily="18" charset="0"/>
                                 </a:rPr>
                               </m:ctrlPr>
@@ -12327,7 +12176,7 @@
                     <m:sSub>
                       <m:sSubPr>
                         <m:ctrlPr>
-                          <a:rPr lang="ar-AE" i="1">
+                          <a:rPr lang="ar-AE">
                             <a:latin typeface="Cambria Math" panose="02040503050406030204" pitchFamily="18" charset="0"/>
                           </a:rPr>
                         </m:ctrlPr>
@@ -12370,7 +12219,7 @@
                     <m:sSup>
                       <m:sSupPr>
                         <m:ctrlPr>
-                          <a:rPr lang="ar-AE" i="1">
+                          <a:rPr lang="ar-AE">
                             <a:latin typeface="Cambria Math" panose="02040503050406030204" pitchFamily="18" charset="0"/>
                           </a:rPr>
                         </m:ctrlPr>
@@ -12388,13 +12237,7 @@
                           <a:rPr lang="ar-AE">
                             <a:latin typeface="Cambria Math" panose="02040503050406030204" pitchFamily="18" charset="0"/>
                           </a:rPr>
-                          <m:t>𝑡</m:t>
-                        </m:r>
-                        <m:r>
-                          <a:rPr lang="ar-AE">
-                            <a:latin typeface="Cambria Math" panose="02040503050406030204" pitchFamily="18" charset="0"/>
-                          </a:rPr>
-                          <m:t>h</m:t>
+                          <m:t>𝑡ℎ</m:t>
                         </m:r>
                       </m:sup>
                     </m:sSup>
@@ -12419,7 +12262,7 @@
                     <m:sSub>
                       <m:sSubPr>
                         <m:ctrlPr>
-                          <a:rPr lang="ar-AE" i="1">
+                          <a:rPr lang="ar-AE">
                             <a:latin typeface="Cambria Math" panose="02040503050406030204" pitchFamily="18" charset="0"/>
                           </a:rPr>
                         </m:ctrlPr>
@@ -12846,7 +12689,7 @@
                     <m:sSub>
                       <m:sSubPr>
                         <m:ctrlPr>
-                          <a:rPr lang="ar-AE" sz="2000" i="1" smtClean="0">
+                          <a:rPr lang="ar-AE" sz="2000" i="1">
                             <a:latin typeface="Cambria Math" panose="02040503050406030204" pitchFamily="18" charset="0"/>
                           </a:rPr>
                         </m:ctrlPr>
@@ -12893,19 +12736,14 @@
                           <a:rPr lang="ar-AE" sz="2000" i="1">
                             <a:latin typeface="Cambria Math" panose="02040503050406030204" pitchFamily="18" charset="0"/>
                           </a:rPr>
-                          <m:t>0</m:t>
-                        </m:r>
-                        <m:r>
-                          <a:rPr lang="ar-AE" sz="2000" i="1">
-                            <a:latin typeface="Cambria Math" panose="02040503050406030204" pitchFamily="18" charset="0"/>
-                          </a:rPr>
-                          <m:t>,</m:t>
+                          <m:t>0,</m:t>
                         </m:r>
                         <m:sSup>
                           <m:sSupPr>
                             <m:ctrlPr>
                               <a:rPr lang="ar-AE" sz="2000" i="1">
                                 <a:latin typeface="Cambria Math" panose="02040503050406030204" pitchFamily="18" charset="0"/>
+                                <a:ea typeface="Cambria Math" panose="02040503050406030204" pitchFamily="18" charset="0"/>
                               </a:rPr>
                             </m:ctrlPr>
                           </m:sSupPr>
@@ -13701,13 +13539,7 @@
                       <a:rPr sz="2000">
                         <a:latin typeface="Cambria Math" panose="02040503050406030204" pitchFamily="18" charset="0"/>
                       </a:rPr>
-                      <m:t>=</m:t>
-                    </m:r>
-                    <m:r>
-                      <a:rPr sz="2000">
-                        <a:latin typeface="Cambria Math" panose="02040503050406030204" pitchFamily="18" charset="0"/>
-                      </a:rPr>
-                      <m:t>1</m:t>
+                      <m:t>=1</m:t>
                     </m:r>
                   </m:oMath>
                 </a14:m>
@@ -14524,14 +14356,11 @@
                 <a:pPr lvl="0"/>
                 <a14:m>
                   <m:oMathPara xmlns:m="http://schemas.openxmlformats.org/officeDocument/2006/math">
-                    <m:oMathParaPr>
-                      <m:jc m:val="centerGroup"/>
-                    </m:oMathParaPr>
-                    <m:oMath xmlns:m="http://schemas.openxmlformats.org/officeDocument/2006/math">
+                    <m:oMath>
                       <m:sSub>
                         <m:sSubPr>
                           <m:ctrlPr>
-                            <a:rPr lang="ar-AE" sz="2000" i="1" smtClean="0">
+                            <a:rPr lang="ar-AE" sz="2000" i="1">
                               <a:latin typeface="Cambria Math" panose="02040503050406030204" pitchFamily="18" charset="0"/>
                             </a:rPr>
                           </m:ctrlPr>
@@ -14578,19 +14407,14 @@
                             <a:rPr lang="ar-AE" sz="2000" i="1">
                               <a:latin typeface="Cambria Math" panose="02040503050406030204" pitchFamily="18" charset="0"/>
                             </a:rPr>
-                            <m:t>0</m:t>
-                          </m:r>
-                          <m:r>
-                            <a:rPr lang="ar-AE" sz="2000" i="1">
-                              <a:latin typeface="Cambria Math" panose="02040503050406030204" pitchFamily="18" charset="0"/>
-                            </a:rPr>
-                            <m:t>,</m:t>
+                            <m:t>0,</m:t>
                           </m:r>
                           <m:sSup>
                             <m:sSupPr>
                               <m:ctrlPr>
                                 <a:rPr lang="ar-AE" sz="2000" i="1">
                                   <a:latin typeface="Cambria Math" panose="02040503050406030204" pitchFamily="18" charset="0"/>
+                                  <a:ea typeface="Cambria Math" panose="02040503050406030204" pitchFamily="18" charset="0"/>
                                 </a:rPr>
                               </m:ctrlPr>
                             </m:sSupPr>
@@ -14633,14 +14457,11 @@
                 <a:pPr/>
                 <a14:m>
                   <m:oMathPara xmlns:m="http://schemas.openxmlformats.org/officeDocument/2006/math">
-                    <m:oMathParaPr>
-                      <m:jc m:val="centerGroup"/>
-                    </m:oMathParaPr>
-                    <m:oMath xmlns:m="http://schemas.openxmlformats.org/officeDocument/2006/math">
+                    <m:oMath>
                       <m:sSub>
                         <m:sSubPr>
                           <m:ctrlPr>
-                            <a:rPr lang="ar-AE" sz="2400" i="1" smtClean="0">
+                            <a:rPr lang="ar-AE" sz="2400">
                               <a:latin typeface="Cambria Math" panose="02040503050406030204" pitchFamily="18" charset="0"/>
                             </a:rPr>
                           </m:ctrlPr>
@@ -14671,7 +14492,7 @@
                       <m:sSub>
                         <m:sSubPr>
                           <m:ctrlPr>
-                            <a:rPr lang="ar-AE" sz="2400" i="1">
+                            <a:rPr lang="en-US" sz="2400" b="0" i="1" smtClean="0">
                               <a:latin typeface="Cambria Math" panose="02040503050406030204" pitchFamily="18" charset="0"/>
                             </a:rPr>
                           </m:ctrlPr>
@@ -14704,7 +14525,7 @@
                           <m:chr m:val="∑"/>
                           <m:limLoc m:val="undOvr"/>
                           <m:ctrlPr>
-                            <a:rPr lang="ar-AE" sz="2400" i="1">
+                            <a:rPr lang="ar-AE" sz="2400">
                               <a:latin typeface="Cambria Math" panose="02040503050406030204" pitchFamily="18" charset="0"/>
                             </a:rPr>
                           </m:ctrlPr>
@@ -14720,13 +14541,7 @@
                             <a:rPr lang="ar-AE" sz="2400">
                               <a:latin typeface="Cambria Math" panose="02040503050406030204" pitchFamily="18" charset="0"/>
                             </a:rPr>
-                            <m:t>=</m:t>
-                          </m:r>
-                          <m:r>
-                            <a:rPr lang="ar-AE" sz="2400">
-                              <a:latin typeface="Cambria Math" panose="02040503050406030204" pitchFamily="18" charset="0"/>
-                            </a:rPr>
-                            <m:t>0</m:t>
+                            <m:t>=0</m:t>
                           </m:r>
                         </m:sub>
                         <m:sup>
@@ -14740,20 +14555,14 @@
                             <a:rPr lang="ar-AE" sz="2400">
                               <a:latin typeface="Cambria Math" panose="02040503050406030204" pitchFamily="18" charset="0"/>
                             </a:rPr>
-                            <m:t>−</m:t>
-                          </m:r>
-                          <m:r>
-                            <a:rPr lang="ar-AE" sz="2400">
-                              <a:latin typeface="Cambria Math" panose="02040503050406030204" pitchFamily="18" charset="0"/>
-                            </a:rPr>
-                            <m:t>1</m:t>
+                            <m:t>−1</m:t>
                           </m:r>
                         </m:sup>
                         <m:e>
                           <m:sSub>
                             <m:sSubPr>
                               <m:ctrlPr>
-                                <a:rPr lang="ar-AE" sz="2400" i="1">
+                                <a:rPr lang="ar-AE" sz="2400">
                                   <a:latin typeface="Cambria Math" panose="02040503050406030204" pitchFamily="18" charset="0"/>
                                 </a:rPr>
                               </m:ctrlPr>
@@ -15042,11 +14851,11 @@
                     <m:oMathParaPr>
                       <m:jc m:val="center"/>
                     </m:oMathParaPr>
-                    <m:oMath xmlns:m="http://schemas.openxmlformats.org/officeDocument/2006/math">
+                    <m:oMath>
                       <m:sSub>
                         <m:sSubPr>
                           <m:ctrlPr>
-                            <a:rPr i="1">
+                            <a:rPr>
                               <a:latin typeface="Cambria Math" panose="02040503050406030204" pitchFamily="18" charset="0"/>
                             </a:rPr>
                           </m:ctrlPr>
@@ -15092,7 +14901,7 @@
                           <m:sSub>
                             <m:sSubPr>
                               <m:ctrlPr>
-                                <a:rPr i="1">
+                                <a:rPr>
                                   <a:latin typeface="Cambria Math" panose="02040503050406030204" pitchFamily="18" charset="0"/>
                                 </a:rPr>
                               </m:ctrlPr>
@@ -15123,7 +14932,7 @@
                           <m:sSub>
                             <m:sSubPr>
                               <m:ctrlPr>
-                                <a:rPr i="1">
+                                <a:rPr>
                                   <a:latin typeface="Cambria Math" panose="02040503050406030204" pitchFamily="18" charset="0"/>
                                 </a:rPr>
                               </m:ctrlPr>
@@ -15185,14 +14994,11 @@
                 </a:pPr>
                 <a14:m>
                   <m:oMathPara xmlns:m="http://schemas.openxmlformats.org/officeDocument/2006/math">
-                    <m:oMathParaPr>
-                      <m:jc m:val="centerGroup"/>
-                    </m:oMathParaPr>
-                    <m:oMath xmlns:m="http://schemas.openxmlformats.org/officeDocument/2006/math">
+                    <m:oMath>
                       <m:sSub>
                         <m:sSubPr>
                           <m:ctrlPr>
-                            <a:rPr i="1">
+                            <a:rPr>
                               <a:latin typeface="Cambria Math" panose="02040503050406030204" pitchFamily="18" charset="0"/>
                             </a:rPr>
                           </m:ctrlPr>
@@ -15238,7 +15044,7 @@
                           <m:sSub>
                             <m:sSubPr>
                               <m:ctrlPr>
-                                <a:rPr i="1">
+                                <a:rPr>
                                   <a:latin typeface="Cambria Math" panose="02040503050406030204" pitchFamily="18" charset="0"/>
                                 </a:rPr>
                               </m:ctrlPr>
@@ -15269,7 +15075,7 @@
                           <m:sSub>
                             <m:sSubPr>
                               <m:ctrlPr>
-                                <a:rPr i="1">
+                                <a:rPr>
                                   <a:latin typeface="Cambria Math" panose="02040503050406030204" pitchFamily="18" charset="0"/>
                                 </a:rPr>
                               </m:ctrlPr>
@@ -15320,7 +15126,7 @@
                       <m:sSup>
                         <m:sSupPr>
                           <m:ctrlPr>
-                            <a:rPr i="1">
+                            <a:rPr>
                               <a:latin typeface="Cambria Math" panose="02040503050406030204" pitchFamily="18" charset="0"/>
                             </a:rPr>
                           </m:ctrlPr>
@@ -15346,19 +15152,7 @@
                         <a:rPr>
                           <a:latin typeface="Cambria Math" panose="02040503050406030204" pitchFamily="18" charset="0"/>
                         </a:rPr>
-                        <m:t>→</m:t>
-                      </m:r>
-                      <m:r>
-                        <a:rPr>
-                          <a:latin typeface="Cambria Math" panose="02040503050406030204" pitchFamily="18" charset="0"/>
-                        </a:rPr>
-                        <m:t>∞</m:t>
-                      </m:r>
-                      <m:r>
-                        <a:rPr>
-                          <a:latin typeface="Cambria Math" panose="02040503050406030204" pitchFamily="18" charset="0"/>
-                        </a:rPr>
-                        <m:t> </m:t>
+                        <m:t>→∞ </m:t>
                       </m:r>
                       <m:r>
                         <a:rPr>
@@ -15382,13 +15176,7 @@
                         <a:rPr>
                           <a:latin typeface="Cambria Math" panose="02040503050406030204" pitchFamily="18" charset="0"/>
                         </a:rPr>
-                        <m:t>→</m:t>
-                      </m:r>
-                      <m:r>
-                        <a:rPr>
-                          <a:latin typeface="Cambria Math" panose="02040503050406030204" pitchFamily="18" charset="0"/>
-                        </a:rPr>
-                        <m:t>∞</m:t>
+                        <m:t>→∞</m:t>
                       </m:r>
                     </m:oMath>
                   </m:oMathPara>
@@ -16297,10 +16085,7 @@
                 <a:pPr lvl="0"/>
                 <a14:m>
                   <m:oMathPara xmlns:m="http://schemas.openxmlformats.org/officeDocument/2006/math">
-                    <m:oMathParaPr>
-                      <m:jc m:val="centerGroup"/>
-                    </m:oMathParaPr>
-                    <m:oMath xmlns:m="http://schemas.openxmlformats.org/officeDocument/2006/math">
+                    <m:oMath>
                       <m:r>
                         <m:rPr>
                           <m:sty m:val="p"/>
@@ -16314,7 +16099,7 @@
                       <m:sSub>
                         <m:sSubPr>
                           <m:ctrlPr>
-                            <a:rPr lang="el-GR" sz="2000" i="1" smtClean="0">
+                            <a:rPr lang="en-US" sz="2000" b="0" i="1" smtClean="0">
                               <a:latin typeface="Cambria Math" panose="02040503050406030204" pitchFamily="18" charset="0"/>
                               <a:ea typeface="Cambria Math" panose="02040503050406030204" pitchFamily="18" charset="0"/>
                             </a:rPr>
@@ -16348,7 +16133,7 @@
                       <m:sSub>
                         <m:sSubPr>
                           <m:ctrlPr>
-                            <a:rPr lang="ar-AE" sz="2000" i="1">
+                            <a:rPr lang="ar-AE" sz="2000">
                               <a:latin typeface="Cambria Math" panose="02040503050406030204" pitchFamily="18" charset="0"/>
                             </a:rPr>
                           </m:ctrlPr>
@@ -16379,7 +16164,7 @@
                       <m:sSub>
                         <m:sSubPr>
                           <m:ctrlPr>
-                            <a:rPr lang="ar-AE" sz="2000" i="1">
+                            <a:rPr lang="ar-AE" sz="2000">
                               <a:latin typeface="Cambria Math" panose="02040503050406030204" pitchFamily="18" charset="0"/>
                             </a:rPr>
                           </m:ctrlPr>
@@ -16403,13 +16188,7 @@
                             <a:rPr lang="ar-AE" sz="2000">
                               <a:latin typeface="Cambria Math" panose="02040503050406030204" pitchFamily="18" charset="0"/>
                             </a:rPr>
-                            <m:t>−</m:t>
-                          </m:r>
-                          <m:r>
-                            <a:rPr lang="ar-AE" sz="2000">
-                              <a:latin typeface="Cambria Math" panose="02040503050406030204" pitchFamily="18" charset="0"/>
-                            </a:rPr>
-                            <m:t>1</m:t>
+                            <m:t>−1</m:t>
                           </m:r>
                         </m:sub>
                       </m:sSub>
@@ -16452,14 +16231,11 @@
                 <a:pPr lvl="0"/>
                 <a14:m>
                   <m:oMathPara xmlns:m="http://schemas.openxmlformats.org/officeDocument/2006/math">
-                    <m:oMathParaPr>
-                      <m:jc m:val="centerGroup"/>
-                    </m:oMathParaPr>
-                    <m:oMath xmlns:m="http://schemas.openxmlformats.org/officeDocument/2006/math">
+                    <m:oMath>
                       <m:sSub>
                         <m:sSubPr>
                           <m:ctrlPr>
-                            <a:rPr lang="ar-AE" sz="2000" i="1">
+                            <a:rPr lang="ar-AE" sz="2000">
                               <a:latin typeface="Cambria Math" panose="02040503050406030204" pitchFamily="18" charset="0"/>
                             </a:rPr>
                           </m:ctrlPr>
@@ -16490,7 +16266,7 @@
                       <m:sSub>
                         <m:sSubPr>
                           <m:ctrlPr>
-                            <a:rPr lang="ar-AE" sz="2000" i="1">
+                            <a:rPr lang="en-US" sz="2000" i="1">
                               <a:latin typeface="Cambria Math" panose="02040503050406030204" pitchFamily="18" charset="0"/>
                             </a:rPr>
                           </m:ctrlPr>
@@ -16523,7 +16299,7 @@
                           <m:chr m:val="∑"/>
                           <m:limLoc m:val="undOvr"/>
                           <m:ctrlPr>
-                            <a:rPr lang="ar-AE" sz="2000" i="1">
+                            <a:rPr lang="ar-AE" sz="2000">
                               <a:latin typeface="Cambria Math" panose="02040503050406030204" pitchFamily="18" charset="0"/>
                             </a:rPr>
                           </m:ctrlPr>
@@ -16539,13 +16315,7 @@
                             <a:rPr lang="ar-AE" sz="2000">
                               <a:latin typeface="Cambria Math" panose="02040503050406030204" pitchFamily="18" charset="0"/>
                             </a:rPr>
-                            <m:t>=</m:t>
-                          </m:r>
-                          <m:r>
-                            <a:rPr lang="ar-AE" sz="2000">
-                              <a:latin typeface="Cambria Math" panose="02040503050406030204" pitchFamily="18" charset="0"/>
-                            </a:rPr>
-                            <m:t>0</m:t>
+                            <m:t>=0</m:t>
                           </m:r>
                         </m:sub>
                         <m:sup>
@@ -16559,13 +16329,7 @@
                             <a:rPr lang="ar-AE" sz="2000">
                               <a:latin typeface="Cambria Math" panose="02040503050406030204" pitchFamily="18" charset="0"/>
                             </a:rPr>
-                            <m:t>−</m:t>
-                          </m:r>
-                          <m:r>
-                            <a:rPr lang="ar-AE" sz="2000">
-                              <a:latin typeface="Cambria Math" panose="02040503050406030204" pitchFamily="18" charset="0"/>
-                            </a:rPr>
-                            <m:t>1</m:t>
+                            <m:t>−1</m:t>
                           </m:r>
                         </m:sup>
                         <m:e>
@@ -16582,7 +16346,7 @@
                           <m:sSub>
                             <m:sSubPr>
                               <m:ctrlPr>
-                                <a:rPr lang="el-GR" sz="2000" i="1">
+                                <a:rPr lang="en-US" sz="2000" i="1">
                                   <a:latin typeface="Cambria Math" panose="02040503050406030204" pitchFamily="18" charset="0"/>
                                   <a:ea typeface="Cambria Math" panose="02040503050406030204" pitchFamily="18" charset="0"/>
                                 </a:rPr>
@@ -17993,8 +17757,8 @@
           </a:p>
         </p:txBody>
       </p:sp>
-      <mc:AlternateContent xmlns:mc="http://schemas.openxmlformats.org/markup-compatibility/2006">
-        <mc:Choice xmlns:a14="http://schemas.microsoft.com/office/drawing/2010/main" Requires="a14">
+      <mc:AlternateContent xmlns:mc="http://schemas.openxmlformats.org/markup-compatibility/2006" xmlns:a14="http://schemas.microsoft.com/office/drawing/2010/main">
+        <mc:Choice Requires="a14">
           <p:sp>
             <p:nvSpPr>
               <p:cNvPr id="3" name="Content Placeholder 2"/>
@@ -18141,7 +17905,7 @@
             </p:txBody>
           </p:sp>
         </mc:Choice>
-        <mc:Fallback>
+        <mc:Fallback xmlns="">
           <p:sp>
             <p:nvSpPr>
               <p:cNvPr id="3" name="Content Placeholder 2"/>
@@ -18773,30 +18537,34 @@
           <a:p>
             <a:pPr lvl="1"/>
             <a:r>
+              <a:rPr b="1" dirty="0"/>
+              <a:t>Serial correlation of values</a:t>
+            </a:r>
+          </a:p>
+          <a:p>
+            <a:pPr lvl="1"/>
+            <a:r>
+              <a:rPr b="1" dirty="0"/>
+              <a:t>Serial correlation of errors</a:t>
+            </a:r>
+          </a:p>
+          <a:p>
+            <a:pPr lvl="1"/>
+            <a:r>
+              <a:rPr b="1" dirty="0"/>
+              <a:t>Violate </a:t>
+            </a:r>
+            <a:r>
+              <a:rPr b="1" dirty="0" err="1"/>
+              <a:t>iid</a:t>
+            </a:r>
+            <a:r>
+              <a:rPr b="1" dirty="0"/>
+              <a:t> assumptions </a:t>
+            </a:r>
+            <a:r>
               <a:rPr dirty="0"/>
-              <a:t>Serial correlation of values</a:t>
-            </a:r>
-          </a:p>
-          <a:p>
-            <a:pPr lvl="1"/>
-            <a:r>
-              <a:rPr dirty="0"/>
-              <a:t>Serial correlation of errors</a:t>
-            </a:r>
-          </a:p>
-          <a:p>
-            <a:pPr lvl="1"/>
-            <a:r>
-              <a:rPr dirty="0"/>
-              <a:t>Violate </a:t>
-            </a:r>
-            <a:r>
-              <a:rPr dirty="0" err="1"/>
-              <a:t>iid</a:t>
-            </a:r>
-            <a:r>
-              <a:rPr dirty="0"/>
-              <a:t> assumptions of many statistical and ML Models</a:t>
+              <a:t>of many statistical and ML Models</a:t>
             </a:r>
             <a:br>
               <a:rPr dirty="0"/>
@@ -21617,7 +21385,7 @@
                     <m:oMathParaPr>
                       <m:jc m:val="center"/>
                     </m:oMathParaPr>
-                    <m:oMath xmlns:m="http://schemas.openxmlformats.org/officeDocument/2006/math">
+                    <m:oMath>
                       <m:r>
                         <a:rPr>
                           <a:latin typeface="Cambria Math" panose="02040503050406030204" pitchFamily="18" charset="0"/>
@@ -21627,7 +21395,7 @@
                       <m:d>
                         <m:dPr>
                           <m:ctrlPr>
-                            <a:rPr i="1">
+                            <a:rPr>
                               <a:latin typeface="Cambria Math" panose="02040503050406030204" pitchFamily="18" charset="0"/>
                             </a:rPr>
                           </m:ctrlPr>
@@ -21656,7 +21424,7 @@
                       <m:d>
                         <m:dPr>
                           <m:ctrlPr>
-                            <a:rPr i="1">
+                            <a:rPr>
                               <a:latin typeface="Cambria Math" panose="02040503050406030204" pitchFamily="18" charset="0"/>
                             </a:rPr>
                           </m:ctrlPr>
@@ -21685,7 +21453,7 @@
                       <m:d>
                         <m:dPr>
                           <m:ctrlPr>
-                            <a:rPr i="1">
+                            <a:rPr>
                               <a:latin typeface="Cambria Math" panose="02040503050406030204" pitchFamily="18" charset="0"/>
                             </a:rPr>
                           </m:ctrlPr>
@@ -21714,7 +21482,7 @@
                       <m:d>
                         <m:dPr>
                           <m:ctrlPr>
-                            <a:rPr i="1">
+                            <a:rPr>
                               <a:latin typeface="Cambria Math" panose="02040503050406030204" pitchFamily="18" charset="0"/>
                             </a:rPr>
                           </m:ctrlPr>
@@ -22075,7 +21843,7 @@
                     <m:oMathParaPr>
                       <m:jc m:val="center"/>
                     </m:oMathParaPr>
-                    <m:oMath xmlns:m="http://schemas.openxmlformats.org/officeDocument/2006/math">
+                    <m:oMath>
                       <m:r>
                         <a:rPr>
                           <a:latin typeface="Cambria Math" panose="02040503050406030204" pitchFamily="18" charset="0"/>
@@ -22085,7 +21853,7 @@
                       <m:d>
                         <m:dPr>
                           <m:ctrlPr>
-                            <a:rPr i="1">
+                            <a:rPr>
                               <a:latin typeface="Cambria Math" panose="02040503050406030204" pitchFamily="18" charset="0"/>
                             </a:rPr>
                           </m:ctrlPr>
@@ -22114,7 +21882,7 @@
                       <m:d>
                         <m:dPr>
                           <m:ctrlPr>
-                            <a:rPr i="1">
+                            <a:rPr>
                               <a:latin typeface="Cambria Math" panose="02040503050406030204" pitchFamily="18" charset="0"/>
                             </a:rPr>
                           </m:ctrlPr>
@@ -22143,7 +21911,7 @@
                       <m:d>
                         <m:dPr>
                           <m:ctrlPr>
-                            <a:rPr i="1">
+                            <a:rPr>
                               <a:latin typeface="Cambria Math" panose="02040503050406030204" pitchFamily="18" charset="0"/>
                             </a:rPr>
                           </m:ctrlPr>
@@ -22172,7 +21940,7 @@
                       <m:d>
                         <m:dPr>
                           <m:ctrlPr>
-                            <a:rPr i="1">
+                            <a:rPr>
                               <a:latin typeface="Cambria Math" panose="02040503050406030204" pitchFamily="18" charset="0"/>
                             </a:rPr>
                           </m:ctrlPr>
@@ -22572,14 +22340,11 @@
                 <a:pPr lvl="0"/>
                 <a14:m>
                   <m:oMathPara xmlns:m="http://schemas.openxmlformats.org/officeDocument/2006/math">
-                    <m:oMathParaPr>
-                      <m:jc m:val="centerGroup"/>
-                    </m:oMathParaPr>
-                    <m:oMath xmlns:m="http://schemas.openxmlformats.org/officeDocument/2006/math">
+                    <m:oMath>
                       <m:sSub>
                         <m:sSubPr>
                           <m:ctrlPr>
-                            <a:rPr lang="ar-AE" sz="2000" i="1" smtClean="0">
+                            <a:rPr lang="ar-AE" sz="2000" b="0" i="1" smtClean="0">
                               <a:latin typeface="Cambria Math" panose="02040503050406030204" pitchFamily="18" charset="0"/>
                             </a:rPr>
                           </m:ctrlPr>
@@ -22757,7 +22522,7 @@
                     <m:sSub>
                       <m:sSubPr>
                         <m:ctrlPr>
-                          <a:rPr lang="en-US" sz="1850" i="1">
+                          <a:rPr lang="en-US" sz="1850" b="0" i="1" smtClean="0">
                             <a:latin typeface="Cambria Math" panose="02040503050406030204" pitchFamily="18" charset="0"/>
                           </a:rPr>
                         </m:ctrlPr>
@@ -23590,7 +23355,15 @@
             </a:r>
             <a:r>
               <a:rPr dirty="0"/>
-              <a:t> correlation:</a:t>
+              <a:t> correlation</a:t>
+            </a:r>
+            <a:r>
+              <a:rPr lang="en-US" dirty="0"/>
+              <a:t> of values</a:t>
+            </a:r>
+            <a:r>
+              <a:rPr dirty="0"/>
+              <a:t>:</a:t>
             </a:r>
           </a:p>
           <a:p>
@@ -23898,8 +23671,8 @@
           </a:p>
         </p:txBody>
       </p:sp>
-      <mc:AlternateContent xmlns:mc="http://schemas.openxmlformats.org/markup-compatibility/2006">
-        <mc:Choice xmlns:a14="http://schemas.microsoft.com/office/drawing/2010/main" Requires="a14">
+      <mc:AlternateContent xmlns:mc="http://schemas.openxmlformats.org/markup-compatibility/2006" xmlns:a14="http://schemas.microsoft.com/office/drawing/2010/main">
+        <mc:Choice Requires="a14">
           <p:sp>
             <p:nvSpPr>
               <p:cNvPr id="3" name="Content Placeholder 2"/>
@@ -23964,7 +23737,7 @@
                     <m:oMathParaPr>
                       <m:jc m:val="center"/>
                     </m:oMathParaPr>
-                    <m:oMath xmlns:m="http://schemas.openxmlformats.org/officeDocument/2006/math">
+                    <m:oMath>
                       <m:r>
                         <m:rPr>
                           <m:sty m:val="p"/>
@@ -23977,7 +23750,7 @@
                       <m:sSub>
                         <m:sSubPr>
                           <m:ctrlPr>
-                            <a:rPr lang="ar-AE" i="1">
+                            <a:rPr lang="ar-AE">
                               <a:latin typeface="Cambria Math" panose="02040503050406030204" pitchFamily="18" charset="0"/>
                             </a:rPr>
                           </m:ctrlPr>
@@ -24008,7 +23781,7 @@
                       <m:sSub>
                         <m:sSubPr>
                           <m:ctrlPr>
-                            <a:rPr lang="ar-AE" i="1">
+                            <a:rPr lang="ar-AE">
                               <a:latin typeface="Cambria Math" panose="02040503050406030204" pitchFamily="18" charset="0"/>
                             </a:rPr>
                           </m:ctrlPr>
@@ -24039,7 +23812,7 @@
                       <m:sSub>
                         <m:sSubPr>
                           <m:ctrlPr>
-                            <a:rPr lang="ar-AE" i="1">
+                            <a:rPr lang="ar-AE">
                               <a:latin typeface="Cambria Math" panose="02040503050406030204" pitchFamily="18" charset="0"/>
                             </a:rPr>
                           </m:ctrlPr>
@@ -24129,7 +23902,7 @@
             </p:txBody>
           </p:sp>
         </mc:Choice>
-        <mc:Fallback>
+        <mc:Fallback xmlns="">
           <p:sp>
             <p:nvSpPr>
               <p:cNvPr id="3" name="Content Placeholder 2"/>
@@ -24451,8 +24224,8 @@
           </a:p>
         </p:txBody>
       </p:sp>
-      <mc:AlternateContent xmlns:mc="http://schemas.openxmlformats.org/markup-compatibility/2006">
-        <mc:Choice xmlns:a14="http://schemas.microsoft.com/office/drawing/2010/main" Requires="a14">
+      <mc:AlternateContent xmlns:mc="http://schemas.openxmlformats.org/markup-compatibility/2006" xmlns:a14="http://schemas.microsoft.com/office/drawing/2010/main">
+        <mc:Choice Requires="a14">
           <p:sp>
             <p:nvSpPr>
               <p:cNvPr id="3" name="Content Placeholder 2"/>
@@ -24492,7 +24265,7 @@
                     <m:oMathParaPr>
                       <m:jc m:val="center"/>
                     </m:oMathParaPr>
-                    <m:oMath xmlns:m="http://schemas.openxmlformats.org/officeDocument/2006/math">
+                    <m:oMath>
                       <m:r>
                         <m:rPr>
                           <m:sty m:val="p"/>
@@ -24505,7 +24278,7 @@
                       <m:sSub>
                         <m:sSubPr>
                           <m:ctrlPr>
-                            <a:rPr lang="ar-AE" i="1">
+                            <a:rPr lang="ar-AE">
                               <a:latin typeface="Cambria Math" panose="02040503050406030204" pitchFamily="18" charset="0"/>
                             </a:rPr>
                           </m:ctrlPr>
@@ -24536,7 +24309,7 @@
                       <m:sSub>
                         <m:sSubPr>
                           <m:ctrlPr>
-                            <a:rPr lang="ar-AE" i="1">
+                            <a:rPr lang="ar-AE">
                               <a:latin typeface="Cambria Math" panose="02040503050406030204" pitchFamily="18" charset="0"/>
                             </a:rPr>
                           </m:ctrlPr>
@@ -24567,7 +24340,7 @@
                       <m:sSub>
                         <m:sSubPr>
                           <m:ctrlPr>
-                            <a:rPr lang="ar-AE" i="1">
+                            <a:rPr lang="ar-AE">
                               <a:latin typeface="Cambria Math" panose="02040503050406030204" pitchFamily="18" charset="0"/>
                             </a:rPr>
                           </m:ctrlPr>
@@ -24660,13 +24433,7 @@
                       <a:rPr lang="en-US">
                         <a:latin typeface="Cambria Math" panose="02040503050406030204" pitchFamily="18" charset="0"/>
                       </a:rPr>
-                      <m:t>=</m:t>
-                    </m:r>
-                    <m:r>
-                      <a:rPr lang="en-US">
-                        <a:latin typeface="Cambria Math" panose="02040503050406030204" pitchFamily="18" charset="0"/>
-                      </a:rPr>
-                      <m:t>1</m:t>
+                      <m:t>=1</m:t>
                     </m:r>
                   </m:oMath>
                 </a14:m>
@@ -24766,6 +24533,7 @@
                         <m:ctrlPr>
                           <a:rPr lang="en-US" i="1" smtClean="0">
                             <a:latin typeface="Cambria Math" panose="02040503050406030204" pitchFamily="18" charset="0"/>
+                            <a:ea typeface="Cambria Math" panose="02040503050406030204" pitchFamily="18" charset="0"/>
                           </a:rPr>
                         </m:ctrlPr>
                       </m:sSubPr>
@@ -24803,6 +24571,7 @@
                         <m:ctrlPr>
                           <a:rPr lang="en-US" i="1">
                             <a:latin typeface="Cambria Math" panose="02040503050406030204" pitchFamily="18" charset="0"/>
+                            <a:ea typeface="Cambria Math" panose="02040503050406030204" pitchFamily="18" charset="0"/>
                           </a:rPr>
                         </m:ctrlPr>
                       </m:sSubPr>
@@ -24846,6 +24615,7 @@
                         <m:ctrlPr>
                           <a:rPr lang="en-US" i="1">
                             <a:latin typeface="Cambria Math" panose="02040503050406030204" pitchFamily="18" charset="0"/>
+                            <a:ea typeface="Cambria Math" panose="02040503050406030204" pitchFamily="18" charset="0"/>
                           </a:rPr>
                         </m:ctrlPr>
                       </m:sSubPr>
@@ -24883,6 +24653,7 @@
                         <m:ctrlPr>
                           <a:rPr lang="en-US" i="1">
                             <a:latin typeface="Cambria Math" panose="02040503050406030204" pitchFamily="18" charset="0"/>
+                            <a:ea typeface="Cambria Math" panose="02040503050406030204" pitchFamily="18" charset="0"/>
                           </a:rPr>
                         </m:ctrlPr>
                       </m:sSubPr>
@@ -24974,7 +24745,7 @@
             </p:txBody>
           </p:sp>
         </mc:Choice>
-        <mc:Fallback>
+        <mc:Fallback xmlns="">
           <p:sp>
             <p:nvSpPr>
               <p:cNvPr id="3" name="Content Placeholder 2"/>
@@ -25496,14 +25267,11 @@
                 <a:pPr lvl="0"/>
                 <a14:m>
                   <m:oMathPara xmlns:m="http://schemas.openxmlformats.org/officeDocument/2006/math">
-                    <m:oMathParaPr>
-                      <m:jc m:val="centerGroup"/>
-                    </m:oMathParaPr>
-                    <m:oMath xmlns:m="http://schemas.openxmlformats.org/officeDocument/2006/math">
+                    <m:oMath>
                       <m:sSub>
                         <m:sSubPr>
                           <m:ctrlPr>
-                            <a:rPr lang="ar-AE" sz="2000" i="1">
+                            <a:rPr lang="ar-AE" sz="2000">
                               <a:latin typeface="Cambria Math" panose="02040503050406030204" pitchFamily="18" charset="0"/>
                             </a:rPr>
                           </m:ctrlPr>
@@ -25534,7 +25302,7 @@
                       <m:sSub>
                         <m:sSubPr>
                           <m:ctrlPr>
-                            <a:rPr lang="ar-AE" sz="2000" i="1">
+                            <a:rPr lang="ar-AE" sz="2000">
                               <a:latin typeface="Cambria Math" panose="02040503050406030204" pitchFamily="18" charset="0"/>
                             </a:rPr>
                           </m:ctrlPr>
@@ -25558,13 +25326,7 @@
                             <a:rPr lang="ar-AE" sz="2000">
                               <a:latin typeface="Cambria Math" panose="02040503050406030204" pitchFamily="18" charset="0"/>
                             </a:rPr>
-                            <m:t>−</m:t>
-                          </m:r>
-                          <m:r>
-                            <a:rPr lang="ar-AE" sz="2000">
-                              <a:latin typeface="Cambria Math" panose="02040503050406030204" pitchFamily="18" charset="0"/>
-                            </a:rPr>
-                            <m:t>1</m:t>
+                            <m:t>−1</m:t>
                           </m:r>
                         </m:sub>
                       </m:sSub>
@@ -25577,7 +25339,7 @@
                       <m:sSub>
                         <m:sSubPr>
                           <m:ctrlPr>
-                            <a:rPr lang="ar-AE" sz="2000" i="1">
+                            <a:rPr lang="ar-AE" sz="2000">
                               <a:latin typeface="Cambria Math" panose="02040503050406030204" pitchFamily="18" charset="0"/>
                             </a:rPr>
                           </m:ctrlPr>
@@ -25661,19 +25423,14 @@
                             <a:rPr lang="ar-AE" sz="2000" i="1">
                               <a:latin typeface="Cambria Math" panose="02040503050406030204" pitchFamily="18" charset="0"/>
                             </a:rPr>
-                            <m:t>0</m:t>
-                          </m:r>
-                          <m:r>
-                            <a:rPr lang="ar-AE" sz="2000" i="1">
-                              <a:latin typeface="Cambria Math" panose="02040503050406030204" pitchFamily="18" charset="0"/>
-                            </a:rPr>
-                            <m:t>,</m:t>
+                            <m:t>0,</m:t>
                           </m:r>
                           <m:sSup>
                             <m:sSupPr>
                               <m:ctrlPr>
                                 <a:rPr lang="ar-AE" sz="2000" i="1">
                                   <a:latin typeface="Cambria Math" panose="02040503050406030204" pitchFamily="18" charset="0"/>
+                                  <a:ea typeface="Cambria Math" panose="02040503050406030204" pitchFamily="18" charset="0"/>
                                 </a:rPr>
                               </m:ctrlPr>
                             </m:sSupPr>
@@ -25716,10 +25473,7 @@
                 <a:pPr lvl="0"/>
                 <a14:m>
                   <m:oMathPara xmlns:m="http://schemas.openxmlformats.org/officeDocument/2006/math">
-                    <m:oMathParaPr>
-                      <m:jc m:val="centerGroup"/>
-                    </m:oMathParaPr>
-                    <m:oMath xmlns:m="http://schemas.openxmlformats.org/officeDocument/2006/math">
+                    <m:oMath>
                       <m:r>
                         <m:rPr>
                           <m:sty m:val="p"/>
@@ -25732,7 +25486,7 @@
                       <m:sSub>
                         <m:sSubPr>
                           <m:ctrlPr>
-                            <a:rPr lang="ar-AE" sz="2000" i="1">
+                            <a:rPr lang="ar-AE" sz="2000">
                               <a:latin typeface="Cambria Math" panose="02040503050406030204" pitchFamily="18" charset="0"/>
                             </a:rPr>
                           </m:ctrlPr>
@@ -25763,7 +25517,7 @@
                       <m:sSub>
                         <m:sSubPr>
                           <m:ctrlPr>
-                            <a:rPr lang="ar-AE" sz="2000" i="1">
+                            <a:rPr lang="ar-AE" sz="2000">
                               <a:latin typeface="Cambria Math" panose="02040503050406030204" pitchFamily="18" charset="0"/>
                             </a:rPr>
                           </m:ctrlPr>
@@ -25794,7 +25548,7 @@
                       <m:sSub>
                         <m:sSubPr>
                           <m:ctrlPr>
-                            <a:rPr lang="ar-AE" sz="2000" i="1">
+                            <a:rPr lang="ar-AE" sz="2000">
                               <a:latin typeface="Cambria Math" panose="02040503050406030204" pitchFamily="18" charset="0"/>
                             </a:rPr>
                           </m:ctrlPr>
@@ -26575,13 +26329,7 @@
                       <a:rPr lang="en-US" sz="2000" b="0" i="1" smtClean="0">
                         <a:latin typeface="Cambria Math" panose="02040503050406030204" pitchFamily="18" charset="0"/>
                       </a:rPr>
-                      <m:t>&gt;</m:t>
-                    </m:r>
-                    <m:r>
-                      <a:rPr lang="en-US" sz="2000" b="0" i="1" smtClean="0">
-                        <a:latin typeface="Cambria Math" panose="02040503050406030204" pitchFamily="18" charset="0"/>
-                      </a:rPr>
-                      <m:t>0</m:t>
+                      <m:t>&gt;0</m:t>
                     </m:r>
                   </m:oMath>
                 </a14:m>
@@ -27493,11 +27241,11 @@
                     <m:oMathParaPr>
                       <m:jc m:val="center"/>
                     </m:oMathParaPr>
-                    <m:oMath xmlns:m="http://schemas.openxmlformats.org/officeDocument/2006/math">
+                    <m:oMath>
                       <m:sSub>
                         <m:sSubPr>
                           <m:ctrlPr>
-                            <a:rPr lang="ar-AE" i="1">
+                            <a:rPr lang="en-US" b="0" i="1" smtClean="0">
                               <a:latin typeface="Cambria Math" panose="02040503050406030204" pitchFamily="18" charset="0"/>
                             </a:rPr>
                           </m:ctrlPr>
@@ -27528,7 +27276,7 @@
                       <m:sSub>
                         <m:sSubPr>
                           <m:ctrlPr>
-                            <a:rPr lang="ar-AE" i="1">
+                            <a:rPr lang="ar-AE">
                               <a:latin typeface="Cambria Math" panose="02040503050406030204" pitchFamily="18" charset="0"/>
                             </a:rPr>
                           </m:ctrlPr>
@@ -27559,7 +27307,7 @@
                       <m:sSub>
                         <m:sSubPr>
                           <m:ctrlPr>
-                            <a:rPr lang="ar-AE" i="1">
+                            <a:rPr lang="ar-AE">
                               <a:latin typeface="Cambria Math" panose="02040503050406030204" pitchFamily="18" charset="0"/>
                             </a:rPr>
                           </m:ctrlPr>
@@ -27647,6 +27395,7 @@
                         <m:ctrlPr>
                           <a:rPr lang="en-US" i="1" smtClean="0">
                             <a:latin typeface="Cambria Math" panose="02040503050406030204" pitchFamily="18" charset="0"/>
+                            <a:ea typeface="Cambria Math" panose="02040503050406030204" pitchFamily="18" charset="0"/>
                           </a:rPr>
                         </m:ctrlPr>
                       </m:sSubPr>
@@ -27684,6 +27433,7 @@
                         <m:ctrlPr>
                           <a:rPr lang="en-US" i="1">
                             <a:latin typeface="Cambria Math" panose="02040503050406030204" pitchFamily="18" charset="0"/>
+                            <a:ea typeface="Cambria Math" panose="02040503050406030204" pitchFamily="18" charset="0"/>
                           </a:rPr>
                         </m:ctrlPr>
                       </m:sSubPr>
@@ -27721,6 +27471,7 @@
                         <m:ctrlPr>
                           <a:rPr lang="en-US" i="1">
                             <a:latin typeface="Cambria Math" panose="02040503050406030204" pitchFamily="18" charset="0"/>
+                            <a:ea typeface="Cambria Math" panose="02040503050406030204" pitchFamily="18" charset="0"/>
                           </a:rPr>
                         </m:ctrlPr>
                       </m:sSubPr>
@@ -27758,6 +27509,7 @@
                         <m:ctrlPr>
                           <a:rPr lang="en-US" i="1">
                             <a:latin typeface="Cambria Math" panose="02040503050406030204" pitchFamily="18" charset="0"/>
+                            <a:ea typeface="Cambria Math" panose="02040503050406030204" pitchFamily="18" charset="0"/>
                           </a:rPr>
                         </m:ctrlPr>
                       </m:sSubPr>
@@ -27793,14 +27545,11 @@
                 </a:pPr>
                 <a14:m>
                   <m:oMathPara xmlns:m="http://schemas.openxmlformats.org/officeDocument/2006/math">
-                    <m:oMathParaPr>
-                      <m:jc m:val="centerGroup"/>
-                    </m:oMathParaPr>
-                    <m:oMath xmlns:m="http://schemas.openxmlformats.org/officeDocument/2006/math">
+                    <m:oMath>
                       <m:sSub>
                         <m:sSubPr>
                           <m:ctrlPr>
-                            <a:rPr lang="en-US" i="1" smtClean="0">
+                            <a:rPr lang="en-US" b="0" i="1" smtClean="0">
                               <a:latin typeface="Cambria Math" panose="02040503050406030204" pitchFamily="18" charset="0"/>
                             </a:rPr>
                           </m:ctrlPr>
@@ -27842,6 +27591,7 @@
                               <m:ctrlPr>
                                 <a:rPr lang="en-US" i="1">
                                   <a:latin typeface="Cambria Math" panose="02040503050406030204" pitchFamily="18" charset="0"/>
+                                  <a:ea typeface="Cambria Math" panose="02040503050406030204" pitchFamily="18" charset="0"/>
                                 </a:rPr>
                               </m:ctrlPr>
                             </m:sSubPr>
@@ -27870,7 +27620,7 @@
                             <m:rPr>
                               <m:nor/>
                             </m:rPr>
-                            <a:rPr lang="en-US" dirty="0"/>
+                            <a:rPr lang="en-US" i="0" dirty="0"/>
                             <m:t> </m:t>
                           </m:r>
                           <m:sSub>
@@ -27878,6 +27628,7 @@
                               <m:ctrlPr>
                                 <a:rPr lang="en-US" i="1">
                                   <a:latin typeface="Cambria Math" panose="02040503050406030204" pitchFamily="18" charset="0"/>
+                                  <a:ea typeface="Cambria Math" panose="02040503050406030204" pitchFamily="18" charset="0"/>
                                 </a:rPr>
                               </m:ctrlPr>
                             </m:sSubPr>
@@ -27928,9 +27679,7 @@
                       <m:sSub>
                         <m:sSubPr>
                           <m:ctrlPr>
-                            <a:rPr lang="en-US" b="0" i="1" smtClean="0">
-                              <a:latin typeface="Cambria Math" panose="02040503050406030204" pitchFamily="18" charset="0"/>
-                            </a:rPr>
+                            <a:rPr lang="en-US" i="0" dirty="0"/>
                           </m:ctrlPr>
                         </m:sSubPr>
                         <m:e>
@@ -27938,7 +27687,7 @@
                             <m:rPr>
                               <m:nor/>
                             </m:rPr>
-                            <a:rPr lang="en-US" dirty="0"/>
+                            <a:rPr lang="en-US" i="0" dirty="0"/>
                             <m:t> </m:t>
                           </m:r>
                           <m:sSub>
@@ -27946,6 +27695,7 @@
                               <m:ctrlPr>
                                 <a:rPr lang="en-US" i="1">
                                   <a:latin typeface="Cambria Math" panose="02040503050406030204" pitchFamily="18" charset="0"/>
+                                  <a:ea typeface="Cambria Math" panose="02040503050406030204" pitchFamily="18" charset="0"/>
                                 </a:rPr>
                               </m:ctrlPr>
                             </m:sSubPr>
@@ -27996,7 +27746,7 @@
                       <m:sSub>
                         <m:sSubPr>
                           <m:ctrlPr>
-                            <a:rPr lang="en-US" b="0" i="1" smtClean="0">
+                            <a:rPr lang="en-US" i="1">
                               <a:latin typeface="Cambria Math" panose="02040503050406030204" pitchFamily="18" charset="0"/>
                             </a:rPr>
                           </m:ctrlPr>
@@ -28007,6 +27757,7 @@
                               <m:ctrlPr>
                                 <a:rPr lang="en-US" i="1">
                                   <a:latin typeface="Cambria Math" panose="02040503050406030204" pitchFamily="18" charset="0"/>
+                                  <a:ea typeface="Cambria Math" panose="02040503050406030204" pitchFamily="18" charset="0"/>
                                 </a:rPr>
                               </m:ctrlPr>
                             </m:sSubPr>
@@ -28050,13 +27801,7 @@
                             <a:rPr lang="en-US" b="0" i="1" smtClean="0">
                               <a:latin typeface="Cambria Math" panose="02040503050406030204" pitchFamily="18" charset="0"/>
                             </a:rPr>
-                            <m:t>−</m:t>
-                          </m:r>
-                          <m:r>
-                            <a:rPr lang="en-US" b="0" i="1" smtClean="0">
-                              <a:latin typeface="Cambria Math" panose="02040503050406030204" pitchFamily="18" charset="0"/>
-                            </a:rPr>
-                            <m:t>1</m:t>
+                            <m:t>−1</m:t>
                           </m:r>
                         </m:sub>
                       </m:sSub>
@@ -28071,10 +27816,7 @@
                 </a:pPr>
                 <a14:m>
                   <m:oMathPara xmlns:m="http://schemas.openxmlformats.org/officeDocument/2006/math">
-                    <m:oMathParaPr>
-                      <m:jc m:val="centerGroup"/>
-                    </m:oMathParaPr>
-                    <m:oMath xmlns:m="http://schemas.openxmlformats.org/officeDocument/2006/math">
+                    <m:oMath>
                       <m:r>
                         <a:rPr lang="en-US" b="0" i="1" smtClean="0">
                           <a:latin typeface="Cambria Math" panose="02040503050406030204" pitchFamily="18" charset="0"/>
@@ -28169,7 +27911,7 @@
                       <m:d>
                         <m:dPr>
                           <m:ctrlPr>
-                            <a:rPr lang="en-US" b="0" i="1" smtClean="0">
+                            <a:rPr lang="en-US" i="1">
                               <a:latin typeface="Cambria Math" panose="02040503050406030204" pitchFamily="18" charset="0"/>
                             </a:rPr>
                           </m:ctrlPr>
@@ -28202,13 +27944,7 @@
                                 <a:rPr lang="en-US" b="0" i="1" smtClean="0">
                                   <a:latin typeface="Cambria Math" panose="02040503050406030204" pitchFamily="18" charset="0"/>
                                 </a:rPr>
-                                <m:t>−</m:t>
-                              </m:r>
-                              <m:r>
-                                <a:rPr lang="en-US" b="0" i="1" smtClean="0">
-                                  <a:latin typeface="Cambria Math" panose="02040503050406030204" pitchFamily="18" charset="0"/>
-                                </a:rPr>
-                                <m:t>1</m:t>
+                                <m:t>−1</m:t>
                               </m:r>
                             </m:sub>
                           </m:sSub>
@@ -28257,13 +27993,7 @@
                                 <a:rPr lang="en-US" b="0" i="1" smtClean="0">
                                   <a:latin typeface="Cambria Math" panose="02040503050406030204" pitchFamily="18" charset="0"/>
                                 </a:rPr>
-                                <m:t>−</m:t>
-                              </m:r>
-                              <m:r>
-                                <a:rPr lang="en-US" b="0" i="1" smtClean="0">
-                                  <a:latin typeface="Cambria Math" panose="02040503050406030204" pitchFamily="18" charset="0"/>
-                                </a:rPr>
-                                <m:t>1</m:t>
+                                <m:t>−1</m:t>
                               </m:r>
                             </m:sub>
                           </m:sSub>
@@ -29164,14 +28894,11 @@
                 </a:pPr>
                 <a14:m>
                   <m:oMathPara xmlns:m="http://schemas.openxmlformats.org/officeDocument/2006/math">
-                    <m:oMathParaPr>
-                      <m:jc m:val="centerGroup"/>
-                    </m:oMathParaPr>
-                    <m:oMath xmlns:m="http://schemas.openxmlformats.org/officeDocument/2006/math">
+                    <m:oMath>
                       <m:sSub>
                         <m:sSubPr>
                           <m:ctrlPr>
-                            <a:rPr lang="ar-AE" i="1" smtClean="0">
+                            <a:rPr lang="ar-AE">
                               <a:latin typeface="Cambria Math" panose="02040503050406030204" pitchFamily="18" charset="0"/>
                             </a:rPr>
                           </m:ctrlPr>
@@ -29208,7 +28935,7 @@
                       <m:sSub>
                         <m:sSubPr>
                           <m:ctrlPr>
-                            <a:rPr lang="ar-AE" i="1">
+                            <a:rPr lang="ar-AE">
                               <a:latin typeface="Cambria Math" panose="02040503050406030204" pitchFamily="18" charset="0"/>
                             </a:rPr>
                           </m:ctrlPr>
@@ -29232,13 +28959,7 @@
                             <a:rPr lang="ar-AE">
                               <a:latin typeface="Cambria Math" panose="02040503050406030204" pitchFamily="18" charset="0"/>
                             </a:rPr>
-                            <m:t>−</m:t>
-                          </m:r>
-                          <m:r>
-                            <a:rPr lang="ar-AE">
-                              <a:latin typeface="Cambria Math" panose="02040503050406030204" pitchFamily="18" charset="0"/>
-                            </a:rPr>
-                            <m:t>1</m:t>
+                            <m:t>−1</m:t>
                           </m:r>
                         </m:sub>
                       </m:sSub>
@@ -29251,7 +28972,7 @@
                       <m:sSub>
                         <m:sSubPr>
                           <m:ctrlPr>
-                            <a:rPr lang="ar-AE" i="1">
+                            <a:rPr lang="ar-AE">
                               <a:latin typeface="Cambria Math" panose="02040503050406030204" pitchFamily="18" charset="0"/>
                             </a:rPr>
                           </m:ctrlPr>
@@ -29284,14 +29005,11 @@
                 </a:pPr>
                 <a14:m>
                   <m:oMathPara xmlns:m="http://schemas.openxmlformats.org/officeDocument/2006/math">
-                    <m:oMathParaPr>
-                      <m:jc m:val="centerGroup"/>
-                    </m:oMathParaPr>
-                    <m:oMath xmlns:m="http://schemas.openxmlformats.org/officeDocument/2006/math">
+                    <m:oMath>
                       <m:sSub>
                         <m:sSubPr>
                           <m:ctrlPr>
-                            <a:rPr lang="ar-AE" i="1" smtClean="0">
+                            <a:rPr lang="ar-AE">
                               <a:latin typeface="Cambria Math" panose="02040503050406030204" pitchFamily="18" charset="0"/>
                             </a:rPr>
                           </m:ctrlPr>
@@ -29339,19 +29057,14 @@
                             <a:rPr lang="en-US" b="0" i="1" smtClean="0">
                               <a:latin typeface="Cambria Math" panose="02040503050406030204" pitchFamily="18" charset="0"/>
                             </a:rPr>
-                            <m:t>0</m:t>
-                          </m:r>
-                          <m:r>
-                            <a:rPr lang="en-US" b="0" i="1" smtClean="0">
-                              <a:latin typeface="Cambria Math" panose="02040503050406030204" pitchFamily="18" charset="0"/>
-                            </a:rPr>
-                            <m:t>,</m:t>
+                            <m:t>0,</m:t>
                           </m:r>
                           <m:sSup>
                             <m:sSupPr>
                               <m:ctrlPr>
                                 <a:rPr lang="en-US" b="0" i="1" smtClean="0">
                                   <a:latin typeface="Cambria Math" panose="02040503050406030204" pitchFamily="18" charset="0"/>
+                                  <a:ea typeface="Cambria Math" panose="02040503050406030204" pitchFamily="18" charset="0"/>
                                 </a:rPr>
                               </m:ctrlPr>
                             </m:sSupPr>
@@ -29391,7 +29104,7 @@
                     <m:sSub>
                       <m:sSubPr>
                         <m:ctrlPr>
-                          <a:rPr lang="ar-AE" i="1">
+                          <a:rPr lang="ar-AE">
                             <a:latin typeface="Cambria Math" panose="02040503050406030204" pitchFamily="18" charset="0"/>
                           </a:rPr>
                         </m:ctrlPr>
@@ -29424,7 +29137,7 @@
                     <m:sSub>
                       <m:sSubPr>
                         <m:ctrlPr>
-                          <a:rPr lang="ar-AE" i="1">
+                          <a:rPr lang="ar-AE">
                             <a:latin typeface="Cambria Math" panose="02040503050406030204" pitchFamily="18" charset="0"/>
                           </a:rPr>
                         </m:ctrlPr>
@@ -29448,13 +29161,7 @@
                           <a:rPr lang="ar-AE">
                             <a:latin typeface="Cambria Math" panose="02040503050406030204" pitchFamily="18" charset="0"/>
                           </a:rPr>
-                          <m:t>−</m:t>
-                        </m:r>
-                        <m:r>
-                          <a:rPr lang="ar-AE">
-                            <a:latin typeface="Cambria Math" panose="02040503050406030204" pitchFamily="18" charset="0"/>
-                          </a:rPr>
-                          <m:t>1</m:t>
+                          <m:t>−1</m:t>
                         </m:r>
                       </m:sub>
                     </m:sSub>
@@ -29469,7 +29176,7 @@
                     <m:sSub>
                       <m:sSubPr>
                         <m:ctrlPr>
-                          <a:rPr lang="ar-AE" i="1" smtClean="0">
+                          <a:rPr lang="ar-AE">
                             <a:latin typeface="Cambria Math" panose="02040503050406030204" pitchFamily="18" charset="0"/>
                           </a:rPr>
                         </m:ctrlPr>
@@ -29565,13 +29272,7 @@
                       <a:rPr lang="en-US">
                         <a:latin typeface="Cambria Math" panose="02040503050406030204" pitchFamily="18" charset="0"/>
                       </a:rPr>
-                      <m:t>−</m:t>
-                    </m:r>
-                    <m:r>
-                      <a:rPr lang="en-US">
-                        <a:latin typeface="Cambria Math" panose="02040503050406030204" pitchFamily="18" charset="0"/>
-                      </a:rPr>
-                      <m:t>1</m:t>
+                      <m:t>−1</m:t>
                     </m:r>
                   </m:oMath>
                 </a14:m>
@@ -29603,7 +29304,7 @@
                     <m:oMathParaPr>
                       <m:jc m:val="center"/>
                     </m:oMathParaPr>
-                    <m:oMath xmlns:m="http://schemas.openxmlformats.org/officeDocument/2006/math">
+                    <m:oMath>
                       <m:r>
                         <m:rPr>
                           <m:sty m:val="p"/>
@@ -29617,7 +29318,7 @@
                       <m:sSub>
                         <m:sSubPr>
                           <m:ctrlPr>
-                            <a:rPr lang="ar-AE" i="1">
+                            <a:rPr lang="ar-AE">
                               <a:latin typeface="Cambria Math" panose="02040503050406030204" pitchFamily="18" charset="0"/>
                             </a:rPr>
                           </m:ctrlPr>
@@ -29648,7 +29349,7 @@
                       <m:d>
                         <m:dPr>
                           <m:ctrlPr>
-                            <a:rPr lang="ar-AE" i="1">
+                            <a:rPr lang="ar-AE">
                               <a:latin typeface="Cambria Math" panose="02040503050406030204" pitchFamily="18" charset="0"/>
                             </a:rPr>
                           </m:ctrlPr>
@@ -29658,13 +29359,7 @@
                             <a:rPr lang="ar-AE">
                               <a:latin typeface="Cambria Math" panose="02040503050406030204" pitchFamily="18" charset="0"/>
                             </a:rPr>
-                            <m:t>1</m:t>
-                          </m:r>
-                          <m:r>
-                            <a:rPr lang="ar-AE">
-                              <a:latin typeface="Cambria Math" panose="02040503050406030204" pitchFamily="18" charset="0"/>
-                            </a:rPr>
-                            <m:t>−</m:t>
+                            <m:t>1−</m:t>
                           </m:r>
                           <m:r>
                             <a:rPr lang="ar-AE">
@@ -29677,7 +29372,7 @@
                       <m:sSub>
                         <m:sSubPr>
                           <m:ctrlPr>
-                            <a:rPr lang="ar-AE" i="1">
+                            <a:rPr lang="ar-AE">
                               <a:latin typeface="Cambria Math" panose="02040503050406030204" pitchFamily="18" charset="0"/>
                             </a:rPr>
                           </m:ctrlPr>
@@ -29701,13 +29396,7 @@
                             <a:rPr lang="ar-AE">
                               <a:latin typeface="Cambria Math" panose="02040503050406030204" pitchFamily="18" charset="0"/>
                             </a:rPr>
-                            <m:t>−</m:t>
-                          </m:r>
-                          <m:r>
-                            <a:rPr lang="ar-AE">
-                              <a:latin typeface="Cambria Math" panose="02040503050406030204" pitchFamily="18" charset="0"/>
-                            </a:rPr>
-                            <m:t>1</m:t>
+                            <m:t>−1</m:t>
                           </m:r>
                         </m:sub>
                       </m:sSub>
@@ -29720,7 +29409,7 @@
                       <m:sSub>
                         <m:sSubPr>
                           <m:ctrlPr>
-                            <a:rPr lang="ar-AE" i="1">
+                            <a:rPr lang="ar-AE">
                               <a:latin typeface="Cambria Math" panose="02040503050406030204" pitchFamily="18" charset="0"/>
                             </a:rPr>
                           </m:ctrlPr>
@@ -30452,13 +30141,7 @@
                       <a:rPr lang="en-US">
                         <a:latin typeface="Cambria Math" panose="02040503050406030204" pitchFamily="18" charset="0"/>
                       </a:rPr>
-                      <m:t>−</m:t>
-                    </m:r>
-                    <m:r>
-                      <a:rPr lang="en-US">
-                        <a:latin typeface="Cambria Math" panose="02040503050406030204" pitchFamily="18" charset="0"/>
-                      </a:rPr>
-                      <m:t>1</m:t>
+                      <m:t>−1</m:t>
                     </m:r>
                   </m:oMath>
                 </a14:m>
@@ -30490,7 +30173,7 @@
                     <m:oMathParaPr>
                       <m:jc m:val="center"/>
                     </m:oMathParaPr>
-                    <m:oMath xmlns:m="http://schemas.openxmlformats.org/officeDocument/2006/math">
+                    <m:oMath>
                       <m:r>
                         <m:rPr>
                           <m:sty m:val="p"/>
@@ -30511,7 +30194,7 @@
                       <m:sSub>
                         <m:sSubPr>
                           <m:ctrlPr>
-                            <a:rPr lang="ar-AE" i="1">
+                            <a:rPr lang="ar-AE">
                               <a:latin typeface="Cambria Math" panose="02040503050406030204" pitchFamily="18" charset="0"/>
                             </a:rPr>
                           </m:ctrlPr>
@@ -30542,7 +30225,7 @@
                       <m:d>
                         <m:dPr>
                           <m:ctrlPr>
-                            <a:rPr lang="ar-AE" i="1" smtClean="0">
+                            <a:rPr lang="ar-AE">
                               <a:latin typeface="Cambria Math" panose="02040503050406030204" pitchFamily="18" charset="0"/>
                             </a:rPr>
                           </m:ctrlPr>
@@ -30552,13 +30235,7 @@
                             <a:rPr lang="ar-AE">
                               <a:latin typeface="Cambria Math" panose="02040503050406030204" pitchFamily="18" charset="0"/>
                             </a:rPr>
-                            <m:t>1</m:t>
-                          </m:r>
-                          <m:r>
-                            <a:rPr lang="ar-AE">
-                              <a:latin typeface="Cambria Math" panose="02040503050406030204" pitchFamily="18" charset="0"/>
-                            </a:rPr>
-                            <m:t>−</m:t>
+                            <m:t>1−</m:t>
                           </m:r>
                           <m:r>
                             <a:rPr lang="ar-AE">
@@ -30571,7 +30248,7 @@
                       <m:sSub>
                         <m:sSubPr>
                           <m:ctrlPr>
-                            <a:rPr lang="ar-AE" i="1">
+                            <a:rPr lang="ar-AE">
                               <a:latin typeface="Cambria Math" panose="02040503050406030204" pitchFamily="18" charset="0"/>
                             </a:rPr>
                           </m:ctrlPr>
@@ -30595,13 +30272,7 @@
                             <a:rPr lang="ar-AE">
                               <a:latin typeface="Cambria Math" panose="02040503050406030204" pitchFamily="18" charset="0"/>
                             </a:rPr>
-                            <m:t>−</m:t>
-                          </m:r>
-                          <m:r>
-                            <a:rPr lang="ar-AE">
-                              <a:latin typeface="Cambria Math" panose="02040503050406030204" pitchFamily="18" charset="0"/>
-                            </a:rPr>
-                            <m:t>1</m:t>
+                            <m:t>−1</m:t>
                           </m:r>
                         </m:sub>
                       </m:sSub>
@@ -30614,7 +30285,7 @@
                       <m:sSub>
                         <m:sSubPr>
                           <m:ctrlPr>
-                            <a:rPr lang="ar-AE" i="1">
+                            <a:rPr lang="ar-AE">
                               <a:latin typeface="Cambria Math" panose="02040503050406030204" pitchFamily="18" charset="0"/>
                             </a:rPr>
                           </m:ctrlPr>
@@ -30659,13 +30330,7 @@
                       <a:rPr lang="en-US">
                         <a:latin typeface="Cambria Math" panose="02040503050406030204" pitchFamily="18" charset="0"/>
                       </a:rPr>
-                      <m:t>=</m:t>
-                    </m:r>
-                    <m:r>
-                      <a:rPr lang="en-US">
-                        <a:latin typeface="Cambria Math" panose="02040503050406030204" pitchFamily="18" charset="0"/>
-                      </a:rPr>
-                      <m:t>1</m:t>
+                      <m:t>=1</m:t>
                     </m:r>
                   </m:oMath>
                 </a14:m>
@@ -30689,7 +30354,7 @@
                     <m:sSub>
                       <m:sSubPr>
                         <m:ctrlPr>
-                          <a:rPr lang="ar-AE" i="1">
+                          <a:rPr lang="ar-AE">
                             <a:latin typeface="Cambria Math" panose="02040503050406030204" pitchFamily="18" charset="0"/>
                           </a:rPr>
                         </m:ctrlPr>
@@ -30726,7 +30391,7 @@
                     <m:sSub>
                       <m:sSubPr>
                         <m:ctrlPr>
-                          <a:rPr lang="ar-AE" i="1">
+                          <a:rPr lang="ar-AE">
                             <a:latin typeface="Cambria Math" panose="02040503050406030204" pitchFamily="18" charset="0"/>
                           </a:rPr>
                         </m:ctrlPr>
@@ -30750,13 +30415,7 @@
                           <a:rPr lang="ar-AE">
                             <a:latin typeface="Cambria Math" panose="02040503050406030204" pitchFamily="18" charset="0"/>
                           </a:rPr>
-                          <m:t>−</m:t>
-                        </m:r>
-                        <m:r>
-                          <a:rPr lang="ar-AE">
-                            <a:latin typeface="Cambria Math" panose="02040503050406030204" pitchFamily="18" charset="0"/>
-                          </a:rPr>
-                          <m:t>1</m:t>
+                          <m:t>−1</m:t>
                         </m:r>
                       </m:sub>
                     </m:sSub>
@@ -30775,7 +30434,7 @@
                     <m:sSub>
                       <m:sSubPr>
                         <m:ctrlPr>
-                          <a:rPr lang="ar-AE" i="1">
+                          <a:rPr lang="ar-AE">
                             <a:latin typeface="Cambria Math" panose="02040503050406030204" pitchFamily="18" charset="0"/>
                           </a:rPr>
                         </m:ctrlPr>
@@ -30833,11 +30492,11 @@
                     <m:oMathParaPr>
                       <m:jc m:val="center"/>
                     </m:oMathParaPr>
-                    <m:oMath xmlns:m="http://schemas.openxmlformats.org/officeDocument/2006/math">
+                    <m:oMath>
                       <m:sSub>
                         <m:sSubPr>
                           <m:ctrlPr>
-                            <a:rPr lang="ar-AE" i="1">
+                            <a:rPr lang="ar-AE">
                               <a:latin typeface="Cambria Math" panose="02040503050406030204" pitchFamily="18" charset="0"/>
                             </a:rPr>
                           </m:ctrlPr>
@@ -30870,7 +30529,7 @@
                           <m:chr m:val="∑"/>
                           <m:limLoc m:val="undOvr"/>
                           <m:ctrlPr>
-                            <a:rPr lang="ar-AE" i="1">
+                            <a:rPr lang="ar-AE">
                               <a:latin typeface="Cambria Math" panose="02040503050406030204" pitchFamily="18" charset="0"/>
                             </a:rPr>
                           </m:ctrlPr>
@@ -30886,13 +30545,7 @@
                             <a:rPr lang="ar-AE">
                               <a:latin typeface="Cambria Math" panose="02040503050406030204" pitchFamily="18" charset="0"/>
                             </a:rPr>
-                            <m:t>=</m:t>
-                          </m:r>
-                          <m:r>
-                            <a:rPr lang="ar-AE">
-                              <a:latin typeface="Cambria Math" panose="02040503050406030204" pitchFamily="18" charset="0"/>
-                            </a:rPr>
-                            <m:t>0</m:t>
+                            <m:t>=0</m:t>
                           </m:r>
                         </m:sub>
                         <m:sup>
@@ -30907,7 +30560,7 @@
                           <m:sSub>
                             <m:sSubPr>
                               <m:ctrlPr>
-                                <a:rPr lang="ar-AE" i="1">
+                                <a:rPr lang="ar-AE">
                                   <a:latin typeface="Cambria Math" panose="02040503050406030204" pitchFamily="18" charset="0"/>
                                 </a:rPr>
                               </m:ctrlPr>
@@ -31292,11 +30945,11 @@
                     <m:oMathParaPr>
                       <m:jc m:val="center"/>
                     </m:oMathParaPr>
-                    <m:oMath xmlns:m="http://schemas.openxmlformats.org/officeDocument/2006/math">
+                    <m:oMath>
                       <m:sSub>
                         <m:sSubPr>
                           <m:ctrlPr>
-                            <a:rPr i="1">
+                            <a:rPr>
                               <a:latin typeface="Cambria Math" panose="02040503050406030204" pitchFamily="18" charset="0"/>
                             </a:rPr>
                           </m:ctrlPr>
@@ -31329,7 +30982,7 @@
                           <m:chr m:val="∑"/>
                           <m:limLoc m:val="undOvr"/>
                           <m:ctrlPr>
-                            <a:rPr i="1">
+                            <a:rPr>
                               <a:latin typeface="Cambria Math" panose="02040503050406030204" pitchFamily="18" charset="0"/>
                             </a:rPr>
                           </m:ctrlPr>
@@ -31345,13 +30998,7 @@
                             <a:rPr>
                               <a:latin typeface="Cambria Math" panose="02040503050406030204" pitchFamily="18" charset="0"/>
                             </a:rPr>
-                            <m:t>=</m:t>
-                          </m:r>
-                          <m:r>
-                            <a:rPr>
-                              <a:latin typeface="Cambria Math" panose="02040503050406030204" pitchFamily="18" charset="0"/>
-                            </a:rPr>
-                            <m:t>0</m:t>
+                            <m:t>=0</m:t>
                           </m:r>
                         </m:sub>
                         <m:sup>
@@ -31366,7 +31013,7 @@
                           <m:sSub>
                             <m:sSubPr>
                               <m:ctrlPr>
-                                <a:rPr i="1">
+                                <a:rPr>
                                   <a:latin typeface="Cambria Math" panose="02040503050406030204" pitchFamily="18" charset="0"/>
                                 </a:rPr>
                               </m:ctrlPr>
@@ -31550,7 +31197,7 @@
                     <m:oMathParaPr>
                       <m:jc m:val="center"/>
                     </m:oMathParaPr>
-                    <m:oMath xmlns:m="http://schemas.openxmlformats.org/officeDocument/2006/math">
+                    <m:oMath>
                       <m:r>
                         <m:rPr>
                           <m:sty m:val="p"/>
@@ -31571,7 +31218,7 @@
                       <m:sSub>
                         <m:sSubPr>
                           <m:ctrlPr>
-                            <a:rPr lang="ar-AE" i="1">
+                            <a:rPr lang="ar-AE">
                               <a:latin typeface="Cambria Math" panose="02040503050406030204" pitchFamily="18" charset="0"/>
                             </a:rPr>
                           </m:ctrlPr>
@@ -31602,7 +31249,7 @@
                       <m:d>
                         <m:dPr>
                           <m:ctrlPr>
-                            <a:rPr lang="ar-AE" i="1">
+                            <a:rPr lang="ar-AE">
                               <a:latin typeface="Cambria Math" panose="02040503050406030204" pitchFamily="18" charset="0"/>
                             </a:rPr>
                           </m:ctrlPr>
@@ -31612,13 +31259,7 @@
                             <a:rPr lang="ar-AE">
                               <a:latin typeface="Cambria Math" panose="02040503050406030204" pitchFamily="18" charset="0"/>
                             </a:rPr>
-                            <m:t>1</m:t>
-                          </m:r>
-                          <m:r>
-                            <a:rPr lang="ar-AE">
-                              <a:latin typeface="Cambria Math" panose="02040503050406030204" pitchFamily="18" charset="0"/>
-                            </a:rPr>
-                            <m:t>−</m:t>
+                            <m:t>1−</m:t>
                           </m:r>
                           <m:r>
                             <a:rPr lang="ar-AE">
@@ -31631,7 +31272,7 @@
                       <m:sSub>
                         <m:sSubPr>
                           <m:ctrlPr>
-                            <a:rPr lang="ar-AE" i="1">
+                            <a:rPr lang="ar-AE">
                               <a:latin typeface="Cambria Math" panose="02040503050406030204" pitchFamily="18" charset="0"/>
                             </a:rPr>
                           </m:ctrlPr>
@@ -31655,13 +31296,7 @@
                             <a:rPr lang="ar-AE">
                               <a:latin typeface="Cambria Math" panose="02040503050406030204" pitchFamily="18" charset="0"/>
                             </a:rPr>
-                            <m:t>−</m:t>
-                          </m:r>
-                          <m:r>
-                            <a:rPr lang="ar-AE">
-                              <a:latin typeface="Cambria Math" panose="02040503050406030204" pitchFamily="18" charset="0"/>
-                            </a:rPr>
-                            <m:t>1</m:t>
+                            <m:t>−1</m:t>
                           </m:r>
                         </m:sub>
                       </m:sSub>
@@ -31674,7 +31309,7 @@
                       <m:sSub>
                         <m:sSubPr>
                           <m:ctrlPr>
-                            <a:rPr lang="ar-AE" i="1">
+                            <a:rPr lang="ar-AE">
                               <a:latin typeface="Cambria Math" panose="02040503050406030204" pitchFamily="18" charset="0"/>
                             </a:rPr>
                           </m:ctrlPr>
@@ -31737,7 +31372,7 @@
                     <m:sSub>
                       <m:sSubPr>
                         <m:ctrlPr>
-                          <a:rPr lang="ar-AE" i="1">
+                          <a:rPr lang="ar-AE">
                             <a:latin typeface="Cambria Math" panose="02040503050406030204" pitchFamily="18" charset="0"/>
                           </a:rPr>
                         </m:ctrlPr>
@@ -31803,11 +31438,11 @@
                     <m:oMathParaPr>
                       <m:jc m:val="center"/>
                     </m:oMathParaPr>
-                    <m:oMath xmlns:m="http://schemas.openxmlformats.org/officeDocument/2006/math">
+                    <m:oMath>
                       <m:sSub>
                         <m:sSubPr>
                           <m:ctrlPr>
-                            <a:rPr lang="ar-AE" i="1">
+                            <a:rPr lang="ar-AE">
                               <a:latin typeface="Cambria Math" panose="02040503050406030204" pitchFamily="18" charset="0"/>
                             </a:rPr>
                           </m:ctrlPr>
@@ -31856,7 +31491,7 @@
                       <m:sSub>
                         <m:sSubPr>
                           <m:ctrlPr>
-                            <a:rPr lang="ar-AE" i="1">
+                            <a:rPr lang="ar-AE">
                               <a:latin typeface="Cambria Math" panose="02040503050406030204" pitchFamily="18" charset="0"/>
                             </a:rPr>
                           </m:ctrlPr>
@@ -31880,13 +31515,7 @@
                             <a:rPr lang="ar-AE">
                               <a:latin typeface="Cambria Math" panose="02040503050406030204" pitchFamily="18" charset="0"/>
                             </a:rPr>
-                            <m:t>−</m:t>
-                          </m:r>
-                          <m:r>
-                            <a:rPr lang="ar-AE">
-                              <a:latin typeface="Cambria Math" panose="02040503050406030204" pitchFamily="18" charset="0"/>
-                            </a:rPr>
-                            <m:t>1</m:t>
+                            <m:t>−1</m:t>
                           </m:r>
                         </m:sub>
                       </m:sSub>
@@ -31899,7 +31528,7 @@
                       <m:sSub>
                         <m:sSubPr>
                           <m:ctrlPr>
-                            <a:rPr lang="ar-AE" i="1">
+                            <a:rPr lang="ar-AE">
                               <a:latin typeface="Cambria Math" panose="02040503050406030204" pitchFamily="18" charset="0"/>
                             </a:rPr>
                           </m:ctrlPr>
@@ -31974,6 +31603,7 @@
                         <m:ctrlPr>
                           <a:rPr lang="en-US" i="1" smtClean="0">
                             <a:latin typeface="Cambria Math" panose="02040503050406030204" pitchFamily="18" charset="0"/>
+                            <a:ea typeface="Cambria Math" panose="02040503050406030204" pitchFamily="18" charset="0"/>
                           </a:rPr>
                         </m:ctrlPr>
                       </m:sSubPr>
@@ -32020,11 +31650,11 @@
                     <m:oMathParaPr>
                       <m:jc m:val="center"/>
                     </m:oMathParaPr>
-                    <m:oMath xmlns:m="http://schemas.openxmlformats.org/officeDocument/2006/math">
+                    <m:oMath>
                       <m:sSub>
                         <m:sSubPr>
                           <m:ctrlPr>
-                            <a:rPr lang="ar-AE" i="1">
+                            <a:rPr lang="ar-AE">
                               <a:latin typeface="Cambria Math" panose="02040503050406030204" pitchFamily="18" charset="0"/>
                             </a:rPr>
                           </m:ctrlPr>
@@ -32091,7 +31721,7 @@
                       <m:sSub>
                         <m:sSubPr>
                           <m:ctrlPr>
-                            <a:rPr lang="ar-AE" i="1">
+                            <a:rPr lang="ar-AE">
                               <a:latin typeface="Cambria Math" panose="02040503050406030204" pitchFamily="18" charset="0"/>
                             </a:rPr>
                           </m:ctrlPr>
@@ -32115,13 +31745,7 @@
                             <a:rPr lang="ar-AE">
                               <a:latin typeface="Cambria Math" panose="02040503050406030204" pitchFamily="18" charset="0"/>
                             </a:rPr>
-                            <m:t>−</m:t>
-                          </m:r>
-                          <m:r>
-                            <a:rPr lang="ar-AE">
-                              <a:latin typeface="Cambria Math" panose="02040503050406030204" pitchFamily="18" charset="0"/>
-                            </a:rPr>
-                            <m:t>1</m:t>
+                            <m:t>−1</m:t>
                           </m:r>
                         </m:sub>
                       </m:sSub>
@@ -32134,7 +31758,7 @@
                       <m:sSub>
                         <m:sSubPr>
                           <m:ctrlPr>
-                            <a:rPr lang="ar-AE" i="1">
+                            <a:rPr lang="ar-AE">
                               <a:latin typeface="Cambria Math" panose="02040503050406030204" pitchFamily="18" charset="0"/>
                             </a:rPr>
                           </m:ctrlPr>

</xml_diff>

<commit_message>
Commit of assignment notebook
</commit_message>
<xml_diff>
--- a/LectureSlides/11_PropertiesOfTimeSeries.pptx
+++ b/LectureSlides/11_PropertiesOfTimeSeries.pptx
@@ -372,7 +372,7 @@
           <a:p>
             <a:fld id="{241EB5C9-1307-BA42-ABA2-0BC069CD8E7F}" type="datetimeFigureOut">
               <a:rPr lang="en-US" smtClean="0"/>
-              <a:t>10/29/2026</a:t>
+              <a:t>10/30/2026</a:t>
             </a:fld>
             <a:endParaRPr lang="en-US"/>
           </a:p>
@@ -540,7 +540,7 @@
           <a:p>
             <a:fld id="{241EB5C9-1307-BA42-ABA2-0BC069CD8E7F}" type="datetimeFigureOut">
               <a:rPr lang="en-US" smtClean="0"/>
-              <a:t>10/29/2026</a:t>
+              <a:t>10/30/2026</a:t>
             </a:fld>
             <a:endParaRPr lang="en-US"/>
           </a:p>
@@ -718,7 +718,7 @@
           <a:p>
             <a:fld id="{241EB5C9-1307-BA42-ABA2-0BC069CD8E7F}" type="datetimeFigureOut">
               <a:rPr lang="en-US" smtClean="0"/>
-              <a:t>10/29/2026</a:t>
+              <a:t>10/30/2026</a:t>
             </a:fld>
             <a:endParaRPr lang="en-US"/>
           </a:p>
@@ -886,7 +886,7 @@
           <a:p>
             <a:fld id="{241EB5C9-1307-BA42-ABA2-0BC069CD8E7F}" type="datetimeFigureOut">
               <a:rPr lang="en-US" smtClean="0"/>
-              <a:t>10/29/2026</a:t>
+              <a:t>10/30/2026</a:t>
             </a:fld>
             <a:endParaRPr lang="en-US"/>
           </a:p>
@@ -1131,7 +1131,7 @@
           <a:p>
             <a:fld id="{241EB5C9-1307-BA42-ABA2-0BC069CD8E7F}" type="datetimeFigureOut">
               <a:rPr lang="en-US" smtClean="0"/>
-              <a:t>10/29/2026</a:t>
+              <a:t>10/30/2026</a:t>
             </a:fld>
             <a:endParaRPr lang="en-US"/>
           </a:p>
@@ -1416,7 +1416,7 @@
           <a:p>
             <a:fld id="{241EB5C9-1307-BA42-ABA2-0BC069CD8E7F}" type="datetimeFigureOut">
               <a:rPr lang="en-US" smtClean="0"/>
-              <a:t>10/29/2026</a:t>
+              <a:t>10/30/2026</a:t>
             </a:fld>
             <a:endParaRPr lang="en-US"/>
           </a:p>
@@ -1835,7 +1835,7 @@
           <a:p>
             <a:fld id="{241EB5C9-1307-BA42-ABA2-0BC069CD8E7F}" type="datetimeFigureOut">
               <a:rPr lang="en-US" smtClean="0"/>
-              <a:t>10/29/2026</a:t>
+              <a:t>10/30/2026</a:t>
             </a:fld>
             <a:endParaRPr lang="en-US"/>
           </a:p>
@@ -1952,7 +1952,7 @@
           <a:p>
             <a:fld id="{241EB5C9-1307-BA42-ABA2-0BC069CD8E7F}" type="datetimeFigureOut">
               <a:rPr lang="en-US" smtClean="0"/>
-              <a:t>10/29/2026</a:t>
+              <a:t>10/30/2026</a:t>
             </a:fld>
             <a:endParaRPr lang="en-US"/>
           </a:p>
@@ -2047,7 +2047,7 @@
           <a:p>
             <a:fld id="{241EB5C9-1307-BA42-ABA2-0BC069CD8E7F}" type="datetimeFigureOut">
               <a:rPr lang="en-US" smtClean="0"/>
-              <a:t>10/29/2026</a:t>
+              <a:t>10/30/2026</a:t>
             </a:fld>
             <a:endParaRPr lang="en-US"/>
           </a:p>
@@ -2322,7 +2322,7 @@
           <a:p>
             <a:fld id="{241EB5C9-1307-BA42-ABA2-0BC069CD8E7F}" type="datetimeFigureOut">
               <a:rPr lang="en-US" smtClean="0"/>
-              <a:t>10/29/2026</a:t>
+              <a:t>10/30/2026</a:t>
             </a:fld>
             <a:endParaRPr lang="en-US"/>
           </a:p>
@@ -2574,7 +2574,7 @@
           <a:p>
             <a:fld id="{241EB5C9-1307-BA42-ABA2-0BC069CD8E7F}" type="datetimeFigureOut">
               <a:rPr lang="en-US" smtClean="0"/>
-              <a:t>10/29/2026</a:t>
+              <a:t>10/30/2026</a:t>
             </a:fld>
             <a:endParaRPr lang="en-US"/>
           </a:p>
@@ -2785,7 +2785,7 @@
           <a:p>
             <a:fld id="{241EB5C9-1307-BA42-ABA2-0BC069CD8E7F}" type="datetimeFigureOut">
               <a:rPr lang="en-US" smtClean="0"/>
-              <a:t>10/29/2026</a:t>
+              <a:t>10/30/2026</a:t>
             </a:fld>
             <a:endParaRPr lang="en-US"/>
           </a:p>
@@ -4808,7 +4808,7 @@
                     <m:d>
                       <m:dPr>
                         <m:ctrlPr>
-                          <a:rPr lang="ar-AE" i="1">
+                          <a:rPr lang="en-US" b="0" i="1" smtClean="0">
                             <a:latin typeface="Cambria Math" panose="02040503050406030204" pitchFamily="18" charset="0"/>
                           </a:rPr>
                         </m:ctrlPr>
@@ -8256,8 +8256,8 @@
           </a:p>
         </p:txBody>
       </p:sp>
-      <mc:AlternateContent xmlns:mc="http://schemas.openxmlformats.org/markup-compatibility/2006">
-        <mc:Choice xmlns:a14="http://schemas.microsoft.com/office/drawing/2010/main" Requires="a14">
+      <mc:AlternateContent xmlns:mc="http://schemas.openxmlformats.org/markup-compatibility/2006" xmlns:a14="http://schemas.microsoft.com/office/drawing/2010/main">
+        <mc:Choice Requires="a14">
           <p:sp>
             <p:nvSpPr>
               <p:cNvPr id="3" name="Content Placeholder 2"/>
@@ -9093,7 +9093,7 @@
             </p:txBody>
           </p:sp>
         </mc:Choice>
-        <mc:Fallback>
+        <mc:Fallback xmlns="">
           <p:sp>
             <p:nvSpPr>
               <p:cNvPr id="3" name="Content Placeholder 2"/>
@@ -9310,8 +9310,8 @@
           </a:p>
         </p:txBody>
       </p:sp>
-      <mc:AlternateContent xmlns:mc="http://schemas.openxmlformats.org/markup-compatibility/2006">
-        <mc:Choice xmlns:a14="http://schemas.microsoft.com/office/drawing/2010/main" Requires="a14">
+      <mc:AlternateContent xmlns:mc="http://schemas.openxmlformats.org/markup-compatibility/2006" xmlns:a14="http://schemas.microsoft.com/office/drawing/2010/main">
+        <mc:Choice Requires="a14">
           <p:sp>
             <p:nvSpPr>
               <p:cNvPr id="3" name="Content Placeholder 2"/>
@@ -9463,7 +9463,7 @@
             </p:txBody>
           </p:sp>
         </mc:Choice>
-        <mc:Fallback>
+        <mc:Fallback xmlns="">
           <p:sp>
             <p:nvSpPr>
               <p:cNvPr id="3" name="Content Placeholder 2"/>
@@ -10242,8 +10242,8 @@
           </a:p>
         </p:txBody>
       </p:sp>
-      <mc:AlternateContent xmlns:mc="http://schemas.openxmlformats.org/markup-compatibility/2006">
-        <mc:Choice xmlns:a14="http://schemas.microsoft.com/office/drawing/2010/main" Requires="a14">
+      <mc:AlternateContent xmlns:mc="http://schemas.openxmlformats.org/markup-compatibility/2006" xmlns:a14="http://schemas.microsoft.com/office/drawing/2010/main">
+        <mc:Choice Requires="a14">
           <p:sp>
             <p:nvSpPr>
               <p:cNvPr id="3" name="Content Placeholder 2"/>
@@ -10606,7 +10606,7 @@
             </p:txBody>
           </p:sp>
         </mc:Choice>
-        <mc:Fallback>
+        <mc:Fallback xmlns="">
           <p:sp>
             <p:nvSpPr>
               <p:cNvPr id="3" name="Content Placeholder 2"/>
@@ -20889,7 +20889,15 @@
             </a:pPr>
             <a:r>
               <a:rPr dirty="0"/>
-              <a:t>Simple model for seasonal effects</a:t>
+              <a:t>Simple model </a:t>
+            </a:r>
+            <a:r>
+              <a:rPr lang="en-US" dirty="0"/>
+              <a:t>to explore</a:t>
+            </a:r>
+            <a:r>
+              <a:rPr dirty="0"/>
+              <a:t> seasonal effects</a:t>
             </a:r>
           </a:p>
           <a:p>
@@ -21791,8 +21799,8 @@
           </a:p>
         </p:txBody>
       </p:sp>
-      <mc:AlternateContent xmlns:mc="http://schemas.openxmlformats.org/markup-compatibility/2006" xmlns:a14="http://schemas.microsoft.com/office/drawing/2010/main">
-        <mc:Choice Requires="a14">
+      <mc:AlternateContent xmlns:mc="http://schemas.openxmlformats.org/markup-compatibility/2006">
+        <mc:Choice xmlns:a14="http://schemas.microsoft.com/office/drawing/2010/main" Requires="a14">
           <p:sp>
             <p:nvSpPr>
               <p:cNvPr id="3" name="Content Placeholder 2"/>
@@ -21978,7 +21986,15 @@
                 <a:pPr lvl="0"/>
                 <a:r>
                   <a:rPr dirty="0"/>
-                  <a:t>Use when seasonal effect changes in time</a:t>
+                  <a:t>Use when seasonal effect </a:t>
+                </a:r>
+                <a:r>
+                  <a:rPr lang="en-US" dirty="0"/>
+                  <a:t>changes with </a:t>
+                </a:r>
+                <a:r>
+                  <a:rPr dirty="0"/>
+                  <a:t>time</a:t>
                 </a:r>
               </a:p>
               <a:p>
@@ -21996,7 +22012,7 @@
             </p:txBody>
           </p:sp>
         </mc:Choice>
-        <mc:Fallback xmlns="">
+        <mc:Fallback>
           <p:sp>
             <p:nvSpPr>
               <p:cNvPr id="3" name="Content Placeholder 2"/>
@@ -27582,6 +27598,7 @@
                           <m:ctrlPr>
                             <a:rPr lang="en-US" i="1">
                               <a:latin typeface="Cambria Math" panose="02040503050406030204" pitchFamily="18" charset="0"/>
+                              <a:ea typeface="Cambria Math" panose="02040503050406030204" pitchFamily="18" charset="0"/>
                             </a:rPr>
                           </m:ctrlPr>
                         </m:sSubPr>
@@ -27748,6 +27765,7 @@
                           <m:ctrlPr>
                             <a:rPr lang="en-US" i="1">
                               <a:latin typeface="Cambria Math" panose="02040503050406030204" pitchFamily="18" charset="0"/>
+                              <a:ea typeface="Cambria Math" panose="02040503050406030204" pitchFamily="18" charset="0"/>
                             </a:rPr>
                           </m:ctrlPr>
                         </m:sSubPr>

</xml_diff>